<commit_message>
Updated Protocols, added python script to accept commands
</commit_message>
<xml_diff>
--- a/docs/Presentation/W03_ PRESENTATION.pptx
+++ b/docs/Presentation/W03_ PRESENTATION.pptx
@@ -6,13 +6,13 @@
   </p:sldMasterIdLst>
   <p:sldIdLst>
     <p:sldId id="256" r:id="rId2"/>
-    <p:sldId id="268" r:id="rId3"/>
-    <p:sldId id="257" r:id="rId4"/>
-    <p:sldId id="264" r:id="rId5"/>
-    <p:sldId id="265" r:id="rId6"/>
-    <p:sldId id="266" r:id="rId7"/>
-    <p:sldId id="267" r:id="rId8"/>
-    <p:sldId id="262" r:id="rId9"/>
+    <p:sldId id="257" r:id="rId3"/>
+    <p:sldId id="264" r:id="rId4"/>
+    <p:sldId id="265" r:id="rId5"/>
+    <p:sldId id="266" r:id="rId6"/>
+    <p:sldId id="267" r:id="rId7"/>
+    <p:sldId id="262" r:id="rId8"/>
+    <p:sldId id="268" r:id="rId9"/>
     <p:sldId id="263" r:id="rId10"/>
   </p:sldIdLst>
   <p:sldSz cx="12192000" cy="6858000"/>
@@ -112,6 +112,11 @@
       </a:defRPr>
     </a:lvl9pPr>
   </p:defaultTextStyle>
+  <p:extLst>
+    <p:ext uri="{EFAFB233-063F-42B5-8137-9DF3F51BA10A}">
+      <p15:sldGuideLst xmlns:p15="http://schemas.microsoft.com/office/powerpoint/2012/main"/>
+    </p:ext>
+  </p:extLst>
 </p:presentation>
 </file>
 
@@ -1048,7 +1053,7 @@
         </a:p>
       </dgm:t>
     </dgm:pt>
-    <dgm:pt modelId="{C9CD50CA-ABF1-481D-B322-A3455A0F8DB0}">
+    <dgm:pt modelId="{365D7F74-FFE5-482B-9D98-39CA7CA0513A}">
       <dgm:prSet/>
       <dgm:spPr/>
       <dgm:t>
@@ -1069,55 +1074,7 @@
               <a:ea typeface="+mn-ea"/>
               <a:cs typeface="+mn-cs"/>
             </a:rPr>
-            <a:t>docs/ARCHITECTURE.md (1–2 pages; simple diagram + explanation)</a:t>
-          </a:r>
-        </a:p>
-      </dgm:t>
-    </dgm:pt>
-    <dgm:pt modelId="{3D784CF8-FD48-47DF-AFDD-7BB541FFEC4F}" type="parTrans" cxnId="{95BBC5A9-B08B-4651-94DB-0FAC4726E8BA}">
-      <dgm:prSet/>
-      <dgm:spPr/>
-      <dgm:t>
-        <a:bodyPr/>
-        <a:lstStyle/>
-        <a:p>
-          <a:endParaRPr lang="en-US"/>
-        </a:p>
-      </dgm:t>
-    </dgm:pt>
-    <dgm:pt modelId="{A9B35914-7BDC-4E1A-AE1E-827EDE30E8C2}" type="sibTrans" cxnId="{95BBC5A9-B08B-4651-94DB-0FAC4726E8BA}">
-      <dgm:prSet/>
-      <dgm:spPr/>
-      <dgm:t>
-        <a:bodyPr/>
-        <a:lstStyle/>
-        <a:p>
-          <a:endParaRPr lang="en-US"/>
-        </a:p>
-      </dgm:t>
-    </dgm:pt>
-    <dgm:pt modelId="{365D7F74-FFE5-482B-9D98-39CA7CA0513A}">
-      <dgm:prSet/>
-      <dgm:spPr/>
-      <dgm:t>
-        <a:bodyPr/>
-        <a:lstStyle/>
-        <a:p>
-          <a:pPr algn="l">
-            <a:lnSpc>
-              <a:spcPct val="90000"/>
-            </a:lnSpc>
-          </a:pPr>
-          <a:r>
-            <a:rPr lang="en-US" sz="2300">
-              <a:solidFill>
-                <a:srgbClr val="FFFFFF"/>
-              </a:solidFill>
-              <a:latin typeface="Aptos" panose="02110004020202020204"/>
-              <a:ea typeface="+mn-ea"/>
-              <a:cs typeface="+mn-cs"/>
-            </a:rPr>
-            <a:t>docs/sprints/W01/plan.md</a:t>
+            <a:t>docs/sprints/W03/plan.md</a:t>
           </a:r>
         </a:p>
       </dgm:t>
@@ -1157,7 +1114,7 @@
             </a:lnSpc>
           </a:pPr>
           <a:r>
-            <a:rPr lang="en-US" sz="2300" b="1">
+            <a:rPr lang="en-US" sz="2300" b="1" dirty="0">
               <a:solidFill>
                 <a:srgbClr val="FFFFFF"/>
               </a:solidFill>
@@ -1168,7 +1125,7 @@
             <a:t> </a:t>
           </a:r>
           <a:r>
-            <a:rPr lang="en-US" sz="2300">
+            <a:rPr lang="en-US" sz="2300" dirty="0">
               <a:solidFill>
                 <a:srgbClr val="FFFFFF"/>
               </a:solidFill>
@@ -1216,7 +1173,7 @@
             </a:lnSpc>
           </a:pPr>
           <a:r>
-            <a:rPr lang="en-US" sz="2300">
+            <a:rPr lang="en-US" sz="2300" dirty="0">
               <a:solidFill>
                 <a:srgbClr val="FFFFFF"/>
               </a:solidFill>
@@ -1224,7 +1181,29 @@
               <a:ea typeface="+mn-ea"/>
               <a:cs typeface="+mn-cs"/>
             </a:rPr>
-            <a:t>sdk/tests/test_import.py </a:t>
+            <a:t>3d Drone </a:t>
+          </a:r>
+          <a:r>
+            <a:rPr lang="en-US" sz="2300" dirty="0" err="1">
+              <a:solidFill>
+                <a:srgbClr val="FFFFFF"/>
+              </a:solidFill>
+              <a:latin typeface="Aptos" panose="02110004020202020204"/>
+              <a:ea typeface="+mn-ea"/>
+              <a:cs typeface="+mn-cs"/>
+            </a:rPr>
+            <a:t>Drone</a:t>
+          </a:r>
+          <a:r>
+            <a:rPr lang="en-US" sz="2300" dirty="0">
+              <a:solidFill>
+                <a:srgbClr val="FFFFFF"/>
+              </a:solidFill>
+              <a:latin typeface="Aptos" panose="02110004020202020204"/>
+              <a:ea typeface="+mn-ea"/>
+              <a:cs typeface="+mn-cs"/>
+            </a:rPr>
+            <a:t> Model inside Project</a:t>
           </a:r>
         </a:p>
       </dgm:t>
@@ -1264,7 +1243,7 @@
             </a:lnSpc>
           </a:pPr>
           <a:r>
-            <a:rPr lang="en-US" sz="2300">
+            <a:rPr lang="en-US" sz="2300" dirty="0">
               <a:solidFill>
                 <a:srgbClr val="FFFFFF"/>
               </a:solidFill>
@@ -1274,7 +1253,7 @@
             </a:rPr>
             <a:t>docs/PROTOCOL.md (updated to match implemented messages)</a:t>
           </a:r>
-          <a:endParaRPr lang="en-US" sz="2300">
+          <a:endParaRPr lang="en-US" sz="2300" dirty="0">
             <a:solidFill>
               <a:srgbClr val="FFFFFF"/>
             </a:solidFill>
@@ -1307,102 +1286,6 @@
         </a:p>
       </dgm:t>
     </dgm:pt>
-    <dgm:pt modelId="{67DBE63C-8A1B-48D5-8856-8FB279741AD4}">
-      <dgm:prSet phldr="0"/>
-      <dgm:spPr/>
-      <dgm:t>
-        <a:bodyPr/>
-        <a:lstStyle/>
-        <a:p>
-          <a:pPr algn="l" rtl="0">
-            <a:lnSpc>
-              <a:spcPct val="90000"/>
-            </a:lnSpc>
-          </a:pPr>
-          <a:r>
-            <a:rPr lang="en-US" sz="2300">
-              <a:solidFill>
-                <a:srgbClr val="FFFFFF"/>
-              </a:solidFill>
-              <a:latin typeface="Calibri"/>
-              <a:ea typeface="Calibri"/>
-              <a:cs typeface="Calibri"/>
-            </a:rPr>
-            <a:t>Docs/sprints/W02/plan.md</a:t>
-          </a:r>
-        </a:p>
-      </dgm:t>
-    </dgm:pt>
-    <dgm:pt modelId="{BA37D9E4-0DBE-4BC2-A1A4-6D791B19AE09}" type="parTrans" cxnId="{15D766B9-6C99-4BDA-BCA3-959E3E99AED2}">
-      <dgm:prSet/>
-      <dgm:spPr/>
-      <dgm:t>
-        <a:bodyPr/>
-        <a:lstStyle/>
-        <a:p>
-          <a:endParaRPr lang="en-US"/>
-        </a:p>
-      </dgm:t>
-    </dgm:pt>
-    <dgm:pt modelId="{DBF9B8DA-D5A1-4656-861D-FE8C4CE654DE}" type="sibTrans" cxnId="{15D766B9-6C99-4BDA-BCA3-959E3E99AED2}">
-      <dgm:prSet/>
-      <dgm:spPr/>
-      <dgm:t>
-        <a:bodyPr/>
-        <a:lstStyle/>
-        <a:p>
-          <a:endParaRPr lang="en-US"/>
-        </a:p>
-      </dgm:t>
-    </dgm:pt>
-    <dgm:pt modelId="{324AB503-E648-4895-9720-93A3A405CE26}">
-      <dgm:prSet phldr="0"/>
-      <dgm:spPr/>
-      <dgm:t>
-        <a:bodyPr/>
-        <a:lstStyle/>
-        <a:p>
-          <a:pPr algn="l" rtl="0">
-            <a:lnSpc>
-              <a:spcPct val="90000"/>
-            </a:lnSpc>
-          </a:pPr>
-          <a:r>
-            <a:rPr lang="en-US" sz="2300">
-              <a:solidFill>
-                <a:srgbClr val="FFFFFF"/>
-              </a:solidFill>
-              <a:latin typeface="Calibri"/>
-              <a:ea typeface="Calibri"/>
-              <a:cs typeface="Calibri"/>
-            </a:rPr>
-            <a:t>docs/presentations/W02.pdf (or W02.pptx)</a:t>
-          </a:r>
-        </a:p>
-      </dgm:t>
-    </dgm:pt>
-    <dgm:pt modelId="{501692F3-CBD3-41B4-B57F-E3EE8AD7A562}" type="parTrans" cxnId="{14A65C43-27B4-4605-813F-C8A5AB30F638}">
-      <dgm:prSet/>
-      <dgm:spPr/>
-      <dgm:t>
-        <a:bodyPr/>
-        <a:lstStyle/>
-        <a:p>
-          <a:endParaRPr lang="en-US"/>
-        </a:p>
-      </dgm:t>
-    </dgm:pt>
-    <dgm:pt modelId="{EA094387-D42A-4167-B317-3CFE4270E1FA}" type="sibTrans" cxnId="{14A65C43-27B4-4605-813F-C8A5AB30F638}">
-      <dgm:prSet/>
-      <dgm:spPr/>
-      <dgm:t>
-        <a:bodyPr/>
-        <a:lstStyle/>
-        <a:p>
-          <a:endParaRPr lang="en-US"/>
-        </a:p>
-      </dgm:t>
-    </dgm:pt>
     <dgm:pt modelId="{072A07C3-6AAB-445D-80A7-249A004FADB9}" type="pres">
       <dgm:prSet presAssocID="{08C5620D-152A-4AB9-9F1D-AACA858352D5}" presName="linear" presStyleCnt="0">
         <dgm:presLayoutVars>
@@ -1412,21 +1295,8 @@
       </dgm:prSet>
       <dgm:spPr/>
     </dgm:pt>
-    <dgm:pt modelId="{8E8C7FFC-61BC-4EC8-B585-066A62D1097E}" type="pres">
-      <dgm:prSet presAssocID="{C9CD50CA-ABF1-481D-B322-A3455A0F8DB0}" presName="parentText" presStyleLbl="node1" presStyleIdx="0" presStyleCnt="7">
-        <dgm:presLayoutVars>
-          <dgm:chMax val="0"/>
-          <dgm:bulletEnabled val="1"/>
-        </dgm:presLayoutVars>
-      </dgm:prSet>
-      <dgm:spPr/>
-    </dgm:pt>
-    <dgm:pt modelId="{6DE6404F-40CC-4E3E-89C0-51CA3752A2B9}" type="pres">
-      <dgm:prSet presAssocID="{A9B35914-7BDC-4E1A-AE1E-827EDE30E8C2}" presName="spacer" presStyleCnt="0"/>
-      <dgm:spPr/>
-    </dgm:pt>
     <dgm:pt modelId="{8694ED8D-E215-4D76-857D-83338FC1B4B1}" type="pres">
-      <dgm:prSet presAssocID="{365D7F74-FFE5-482B-9D98-39CA7CA0513A}" presName="parentText" presStyleLbl="node1" presStyleIdx="1" presStyleCnt="7">
+      <dgm:prSet presAssocID="{365D7F74-FFE5-482B-9D98-39CA7CA0513A}" presName="parentText" presStyleLbl="node1" presStyleIdx="0" presStyleCnt="4">
         <dgm:presLayoutVars>
           <dgm:chMax val="0"/>
           <dgm:bulletEnabled val="1"/>
@@ -1439,7 +1309,7 @@
       <dgm:spPr/>
     </dgm:pt>
     <dgm:pt modelId="{6D8FE49D-26DA-4425-8C7E-DCE94839AD71}" type="pres">
-      <dgm:prSet presAssocID="{EBC24022-F74C-44D4-B421-78DBA0FDC453}" presName="parentText" presStyleLbl="node1" presStyleIdx="2" presStyleCnt="7">
+      <dgm:prSet presAssocID="{EBC24022-F74C-44D4-B421-78DBA0FDC453}" presName="parentText" presStyleLbl="node1" presStyleIdx="1" presStyleCnt="4">
         <dgm:presLayoutVars>
           <dgm:chMax val="0"/>
           <dgm:bulletEnabled val="1"/>
@@ -1452,7 +1322,7 @@
       <dgm:spPr/>
     </dgm:pt>
     <dgm:pt modelId="{09E87734-5520-49F9-A61A-7BFE46AABF34}" type="pres">
-      <dgm:prSet presAssocID="{EDCA3F4A-F7A1-4D91-BF3B-FA626C83CB10}" presName="parentText" presStyleLbl="node1" presStyleIdx="3" presStyleCnt="7">
+      <dgm:prSet presAssocID="{EDCA3F4A-F7A1-4D91-BF3B-FA626C83CB10}" presName="parentText" presStyleLbl="node1" presStyleIdx="2" presStyleCnt="4">
         <dgm:presLayoutVars>
           <dgm:chMax val="0"/>
           <dgm:bulletEnabled val="1"/>
@@ -1465,33 +1335,7 @@
       <dgm:spPr/>
     </dgm:pt>
     <dgm:pt modelId="{8668C22C-39F1-4F13-A3C8-96243DD7C753}" type="pres">
-      <dgm:prSet presAssocID="{F4127BAC-F723-4BA7-9F31-71AEC6B631B0}" presName="parentText" presStyleLbl="node1" presStyleIdx="4" presStyleCnt="7">
-        <dgm:presLayoutVars>
-          <dgm:chMax val="0"/>
-          <dgm:bulletEnabled val="1"/>
-        </dgm:presLayoutVars>
-      </dgm:prSet>
-      <dgm:spPr/>
-    </dgm:pt>
-    <dgm:pt modelId="{0F367B6F-ABE3-43B9-9E29-94C979B603F8}" type="pres">
-      <dgm:prSet presAssocID="{558E3C29-084D-4F27-83BF-79C3E09C0562}" presName="spacer" presStyleCnt="0"/>
-      <dgm:spPr/>
-    </dgm:pt>
-    <dgm:pt modelId="{A3559C65-4E5D-4CA8-85BC-C432C3837387}" type="pres">
-      <dgm:prSet presAssocID="{67DBE63C-8A1B-48D5-8856-8FB279741AD4}" presName="parentText" presStyleLbl="node1" presStyleIdx="5" presStyleCnt="7">
-        <dgm:presLayoutVars>
-          <dgm:chMax val="0"/>
-          <dgm:bulletEnabled val="1"/>
-        </dgm:presLayoutVars>
-      </dgm:prSet>
-      <dgm:spPr/>
-    </dgm:pt>
-    <dgm:pt modelId="{9CFA046C-DF58-4C04-AF2F-BEE95C972E3A}" type="pres">
-      <dgm:prSet presAssocID="{DBF9B8DA-D5A1-4656-861D-FE8C4CE654DE}" presName="spacer" presStyleCnt="0"/>
-      <dgm:spPr/>
-    </dgm:pt>
-    <dgm:pt modelId="{7F0D6C25-7930-47AB-8FBA-CE4FDF55D586}" type="pres">
-      <dgm:prSet presAssocID="{324AB503-E648-4895-9720-93A3A405CE26}" presName="parentText" presStyleLbl="node1" presStyleIdx="6" presStyleCnt="7">
+      <dgm:prSet presAssocID="{F4127BAC-F723-4BA7-9F31-71AEC6B631B0}" presName="parentText" presStyleLbl="node1" presStyleIdx="3" presStyleCnt="4">
         <dgm:presLayoutVars>
           <dgm:chMax val="0"/>
           <dgm:bulletEnabled val="1"/>
@@ -1502,39 +1346,27 @@
   </dgm:ptLst>
   <dgm:cxnLst>
     <dgm:cxn modelId="{22274311-C138-44AB-B457-6F9EB8D5C2D4}" type="presOf" srcId="{EBC24022-F74C-44D4-B421-78DBA0FDC453}" destId="{6D8FE49D-26DA-4425-8C7E-DCE94839AD71}" srcOrd="0" destOrd="0" presId="urn:microsoft.com/office/officeart/2005/8/layout/vList2"/>
-    <dgm:cxn modelId="{92A3561A-8B9C-437C-9AF1-F5B3A0699233}" type="presOf" srcId="{C9CD50CA-ABF1-481D-B322-A3455A0F8DB0}" destId="{8E8C7FFC-61BC-4EC8-B585-066A62D1097E}" srcOrd="0" destOrd="0" presId="urn:microsoft.com/office/officeart/2005/8/layout/vList2"/>
-    <dgm:cxn modelId="{18AB071C-64FA-45F1-B389-C0C680F20A45}" srcId="{08C5620D-152A-4AB9-9F1D-AACA858352D5}" destId="{F4127BAC-F723-4BA7-9F31-71AEC6B631B0}" srcOrd="4" destOrd="0" parTransId="{2755F71C-25C3-42FA-864F-0C3C8AFBE3C4}" sibTransId="{558E3C29-084D-4F27-83BF-79C3E09C0562}"/>
-    <dgm:cxn modelId="{43C3301C-6277-4228-9AF5-835ADEB7A39C}" srcId="{08C5620D-152A-4AB9-9F1D-AACA858352D5}" destId="{365D7F74-FFE5-482B-9D98-39CA7CA0513A}" srcOrd="1" destOrd="0" parTransId="{D17DA32A-B04F-4970-8E9F-C0DF6828DE5B}" sibTransId="{21339A53-A261-43CF-94D6-54DE839026A4}"/>
-    <dgm:cxn modelId="{1EA71A30-8CEE-4080-870A-60B941815164}" srcId="{08C5620D-152A-4AB9-9F1D-AACA858352D5}" destId="{EBC24022-F74C-44D4-B421-78DBA0FDC453}" srcOrd="2" destOrd="0" parTransId="{2DC771CA-2899-4F94-89F6-EED97E2DB446}" sibTransId="{649E8D30-3117-4174-9932-2B174D813E15}"/>
-    <dgm:cxn modelId="{14A65C43-27B4-4605-813F-C8A5AB30F638}" srcId="{08C5620D-152A-4AB9-9F1D-AACA858352D5}" destId="{324AB503-E648-4895-9720-93A3A405CE26}" srcOrd="6" destOrd="0" parTransId="{501692F3-CBD3-41B4-B57F-E3EE8AD7A562}" sibTransId="{EA094387-D42A-4167-B317-3CFE4270E1FA}"/>
-    <dgm:cxn modelId="{A6974950-37A3-4F4C-BC52-2A18802092DD}" type="presOf" srcId="{324AB503-E648-4895-9720-93A3A405CE26}" destId="{7F0D6C25-7930-47AB-8FBA-CE4FDF55D586}" srcOrd="0" destOrd="0" presId="urn:microsoft.com/office/officeart/2005/8/layout/vList2"/>
+    <dgm:cxn modelId="{18AB071C-64FA-45F1-B389-C0C680F20A45}" srcId="{08C5620D-152A-4AB9-9F1D-AACA858352D5}" destId="{F4127BAC-F723-4BA7-9F31-71AEC6B631B0}" srcOrd="3" destOrd="0" parTransId="{2755F71C-25C3-42FA-864F-0C3C8AFBE3C4}" sibTransId="{558E3C29-084D-4F27-83BF-79C3E09C0562}"/>
+    <dgm:cxn modelId="{43C3301C-6277-4228-9AF5-835ADEB7A39C}" srcId="{08C5620D-152A-4AB9-9F1D-AACA858352D5}" destId="{365D7F74-FFE5-482B-9D98-39CA7CA0513A}" srcOrd="0" destOrd="0" parTransId="{D17DA32A-B04F-4970-8E9F-C0DF6828DE5B}" sibTransId="{21339A53-A261-43CF-94D6-54DE839026A4}"/>
+    <dgm:cxn modelId="{1EA71A30-8CEE-4080-870A-60B941815164}" srcId="{08C5620D-152A-4AB9-9F1D-AACA858352D5}" destId="{EBC24022-F74C-44D4-B421-78DBA0FDC453}" srcOrd="1" destOrd="0" parTransId="{2DC771CA-2899-4F94-89F6-EED97E2DB446}" sibTransId="{649E8D30-3117-4174-9932-2B174D813E15}"/>
     <dgm:cxn modelId="{A639098A-624F-4F4A-A760-59486A9A725E}" type="presOf" srcId="{365D7F74-FFE5-482B-9D98-39CA7CA0513A}" destId="{8694ED8D-E215-4D76-857D-83338FC1B4B1}" srcOrd="0" destOrd="0" presId="urn:microsoft.com/office/officeart/2005/8/layout/vList2"/>
-    <dgm:cxn modelId="{7191409F-7EDE-45BD-A6B4-8BA1BDABB0E3}" srcId="{08C5620D-152A-4AB9-9F1D-AACA858352D5}" destId="{EDCA3F4A-F7A1-4D91-BF3B-FA626C83CB10}" srcOrd="3" destOrd="0" parTransId="{E9693187-5B17-43E3-BA6E-69E9E9BEF533}" sibTransId="{7961C441-2E7D-4507-84CE-4BCD89F89971}"/>
-    <dgm:cxn modelId="{790EDAA6-11B9-4594-BB3F-44DC1503C83B}" type="presOf" srcId="{67DBE63C-8A1B-48D5-8856-8FB279741AD4}" destId="{A3559C65-4E5D-4CA8-85BC-C432C3837387}" srcOrd="0" destOrd="0" presId="urn:microsoft.com/office/officeart/2005/8/layout/vList2"/>
-    <dgm:cxn modelId="{95BBC5A9-B08B-4651-94DB-0FAC4726E8BA}" srcId="{08C5620D-152A-4AB9-9F1D-AACA858352D5}" destId="{C9CD50CA-ABF1-481D-B322-A3455A0F8DB0}" srcOrd="0" destOrd="0" parTransId="{3D784CF8-FD48-47DF-AFDD-7BB541FFEC4F}" sibTransId="{A9B35914-7BDC-4E1A-AE1E-827EDE30E8C2}"/>
+    <dgm:cxn modelId="{7191409F-7EDE-45BD-A6B4-8BA1BDABB0E3}" srcId="{08C5620D-152A-4AB9-9F1D-AACA858352D5}" destId="{EDCA3F4A-F7A1-4D91-BF3B-FA626C83CB10}" srcOrd="2" destOrd="0" parTransId="{E9693187-5B17-43E3-BA6E-69E9E9BEF533}" sibTransId="{7961C441-2E7D-4507-84CE-4BCD89F89971}"/>
     <dgm:cxn modelId="{397ECAB7-B016-4663-B04D-F0803B2B1935}" type="presOf" srcId="{08C5620D-152A-4AB9-9F1D-AACA858352D5}" destId="{072A07C3-6AAB-445D-80A7-249A004FADB9}" srcOrd="0" destOrd="0" presId="urn:microsoft.com/office/officeart/2005/8/layout/vList2"/>
-    <dgm:cxn modelId="{15D766B9-6C99-4BDA-BCA3-959E3E99AED2}" srcId="{08C5620D-152A-4AB9-9F1D-AACA858352D5}" destId="{67DBE63C-8A1B-48D5-8856-8FB279741AD4}" srcOrd="5" destOrd="0" parTransId="{BA37D9E4-0DBE-4BC2-A1A4-6D791B19AE09}" sibTransId="{DBF9B8DA-D5A1-4656-861D-FE8C4CE654DE}"/>
     <dgm:cxn modelId="{5FDCBEBE-0F92-47F6-9645-C56D7B959E67}" type="presOf" srcId="{F4127BAC-F723-4BA7-9F31-71AEC6B631B0}" destId="{8668C22C-39F1-4F13-A3C8-96243DD7C753}" srcOrd="0" destOrd="0" presId="urn:microsoft.com/office/officeart/2005/8/layout/vList2"/>
     <dgm:cxn modelId="{7D1DBCEA-D836-4A8E-9475-061860F61421}" type="presOf" srcId="{EDCA3F4A-F7A1-4D91-BF3B-FA626C83CB10}" destId="{09E87734-5520-49F9-A61A-7BFE46AABF34}" srcOrd="0" destOrd="0" presId="urn:microsoft.com/office/officeart/2005/8/layout/vList2"/>
-    <dgm:cxn modelId="{752CB8FC-AE99-4FDB-A3CD-3AE3D18A3900}" type="presParOf" srcId="{072A07C3-6AAB-445D-80A7-249A004FADB9}" destId="{8E8C7FFC-61BC-4EC8-B585-066A62D1097E}" srcOrd="0" destOrd="0" presId="urn:microsoft.com/office/officeart/2005/8/layout/vList2"/>
-    <dgm:cxn modelId="{568FCD3C-51D9-49D0-9688-8FD0A5171327}" type="presParOf" srcId="{072A07C3-6AAB-445D-80A7-249A004FADB9}" destId="{6DE6404F-40CC-4E3E-89C0-51CA3752A2B9}" srcOrd="1" destOrd="0" presId="urn:microsoft.com/office/officeart/2005/8/layout/vList2"/>
-    <dgm:cxn modelId="{68659AF1-62BB-488A-8C0D-9958A8C76943}" type="presParOf" srcId="{072A07C3-6AAB-445D-80A7-249A004FADB9}" destId="{8694ED8D-E215-4D76-857D-83338FC1B4B1}" srcOrd="2" destOrd="0" presId="urn:microsoft.com/office/officeart/2005/8/layout/vList2"/>
-    <dgm:cxn modelId="{3A81852A-F371-43F4-831D-275D1B78AFD1}" type="presParOf" srcId="{072A07C3-6AAB-445D-80A7-249A004FADB9}" destId="{EA64E464-7D77-455D-ACFC-01A130F78390}" srcOrd="3" destOrd="0" presId="urn:microsoft.com/office/officeart/2005/8/layout/vList2"/>
-    <dgm:cxn modelId="{0DDC444E-995D-4085-99AA-06C2BBC5C1EE}" type="presParOf" srcId="{072A07C3-6AAB-445D-80A7-249A004FADB9}" destId="{6D8FE49D-26DA-4425-8C7E-DCE94839AD71}" srcOrd="4" destOrd="0" presId="urn:microsoft.com/office/officeart/2005/8/layout/vList2"/>
-    <dgm:cxn modelId="{8C67D8E3-129C-4D72-94C9-70033AD1067C}" type="presParOf" srcId="{072A07C3-6AAB-445D-80A7-249A004FADB9}" destId="{6AB7D1FF-0E3B-4C3F-BD9E-BCB7095F48F1}" srcOrd="5" destOrd="0" presId="urn:microsoft.com/office/officeart/2005/8/layout/vList2"/>
-    <dgm:cxn modelId="{FF574833-8003-466B-9A1B-C2633A7E40F5}" type="presParOf" srcId="{072A07C3-6AAB-445D-80A7-249A004FADB9}" destId="{09E87734-5520-49F9-A61A-7BFE46AABF34}" srcOrd="6" destOrd="0" presId="urn:microsoft.com/office/officeart/2005/8/layout/vList2"/>
-    <dgm:cxn modelId="{5E9B9D1B-8F89-482D-BBF4-6005D6416C85}" type="presParOf" srcId="{072A07C3-6AAB-445D-80A7-249A004FADB9}" destId="{BE705CF8-4BBE-4F21-8F4A-F7B329CA02E3}" srcOrd="7" destOrd="0" presId="urn:microsoft.com/office/officeart/2005/8/layout/vList2"/>
-    <dgm:cxn modelId="{DAB782EE-45E3-4719-86AA-1F45A9F159B3}" type="presParOf" srcId="{072A07C3-6AAB-445D-80A7-249A004FADB9}" destId="{8668C22C-39F1-4F13-A3C8-96243DD7C753}" srcOrd="8" destOrd="0" presId="urn:microsoft.com/office/officeart/2005/8/layout/vList2"/>
-    <dgm:cxn modelId="{8B49DB83-A4F2-46DA-83BE-C66FF46AC945}" type="presParOf" srcId="{072A07C3-6AAB-445D-80A7-249A004FADB9}" destId="{0F367B6F-ABE3-43B9-9E29-94C979B603F8}" srcOrd="9" destOrd="0" presId="urn:microsoft.com/office/officeart/2005/8/layout/vList2"/>
-    <dgm:cxn modelId="{E2FCF776-4C9D-4FA1-B7CF-C538565DCA91}" type="presParOf" srcId="{072A07C3-6AAB-445D-80A7-249A004FADB9}" destId="{A3559C65-4E5D-4CA8-85BC-C432C3837387}" srcOrd="10" destOrd="0" presId="urn:microsoft.com/office/officeart/2005/8/layout/vList2"/>
-    <dgm:cxn modelId="{7E6C92DF-CC68-4F32-BC6F-A7F4618B0BCA}" type="presParOf" srcId="{072A07C3-6AAB-445D-80A7-249A004FADB9}" destId="{9CFA046C-DF58-4C04-AF2F-BEE95C972E3A}" srcOrd="11" destOrd="0" presId="urn:microsoft.com/office/officeart/2005/8/layout/vList2"/>
-    <dgm:cxn modelId="{D10C6B6B-547D-412A-B2F2-2AE8E4937084}" type="presParOf" srcId="{072A07C3-6AAB-445D-80A7-249A004FADB9}" destId="{7F0D6C25-7930-47AB-8FBA-CE4FDF55D586}" srcOrd="12" destOrd="0" presId="urn:microsoft.com/office/officeart/2005/8/layout/vList2"/>
+    <dgm:cxn modelId="{68659AF1-62BB-488A-8C0D-9958A8C76943}" type="presParOf" srcId="{072A07C3-6AAB-445D-80A7-249A004FADB9}" destId="{8694ED8D-E215-4D76-857D-83338FC1B4B1}" srcOrd="0" destOrd="0" presId="urn:microsoft.com/office/officeart/2005/8/layout/vList2"/>
+    <dgm:cxn modelId="{3A81852A-F371-43F4-831D-275D1B78AFD1}" type="presParOf" srcId="{072A07C3-6AAB-445D-80A7-249A004FADB9}" destId="{EA64E464-7D77-455D-ACFC-01A130F78390}" srcOrd="1" destOrd="0" presId="urn:microsoft.com/office/officeart/2005/8/layout/vList2"/>
+    <dgm:cxn modelId="{0DDC444E-995D-4085-99AA-06C2BBC5C1EE}" type="presParOf" srcId="{072A07C3-6AAB-445D-80A7-249A004FADB9}" destId="{6D8FE49D-26DA-4425-8C7E-DCE94839AD71}" srcOrd="2" destOrd="0" presId="urn:microsoft.com/office/officeart/2005/8/layout/vList2"/>
+    <dgm:cxn modelId="{8C67D8E3-129C-4D72-94C9-70033AD1067C}" type="presParOf" srcId="{072A07C3-6AAB-445D-80A7-249A004FADB9}" destId="{6AB7D1FF-0E3B-4C3F-BD9E-BCB7095F48F1}" srcOrd="3" destOrd="0" presId="urn:microsoft.com/office/officeart/2005/8/layout/vList2"/>
+    <dgm:cxn modelId="{FF574833-8003-466B-9A1B-C2633A7E40F5}" type="presParOf" srcId="{072A07C3-6AAB-445D-80A7-249A004FADB9}" destId="{09E87734-5520-49F9-A61A-7BFE46AABF34}" srcOrd="4" destOrd="0" presId="urn:microsoft.com/office/officeart/2005/8/layout/vList2"/>
+    <dgm:cxn modelId="{5E9B9D1B-8F89-482D-BBF4-6005D6416C85}" type="presParOf" srcId="{072A07C3-6AAB-445D-80A7-249A004FADB9}" destId="{BE705CF8-4BBE-4F21-8F4A-F7B329CA02E3}" srcOrd="5" destOrd="0" presId="urn:microsoft.com/office/officeart/2005/8/layout/vList2"/>
+    <dgm:cxn modelId="{DAB782EE-45E3-4719-86AA-1F45A9F159B3}" type="presParOf" srcId="{072A07C3-6AAB-445D-80A7-249A004FADB9}" destId="{8668C22C-39F1-4F13-A3C8-96243DD7C753}" srcOrd="6" destOrd="0" presId="urn:microsoft.com/office/officeart/2005/8/layout/vList2"/>
   </dgm:cxnLst>
   <dgm:bg/>
   <dgm:whole/>
   <dgm:extLst>
     <a:ext uri="http://schemas.microsoft.com/office/drawing/2008/diagram">
-      <dsp:dataModelExt xmlns:dsp="http://schemas.microsoft.com/office/drawing/2008/diagram" relId="rId7" minVer="http://schemas.openxmlformats.org/drawingml/2006/diagram"/>
+      <dsp:dataModelExt xmlns:dsp="http://schemas.microsoft.com/office/drawing/2008/diagram" relId="rId6" minVer="http://schemas.openxmlformats.org/drawingml/2006/diagram"/>
     </a:ext>
   </dgm:extLst>
 </dgm:dataModel>
@@ -1548,15 +1380,15 @@
       <dsp:cNvGrpSpPr/>
     </dsp:nvGrpSpPr>
     <dsp:grpSpPr/>
-    <dsp:sp modelId="{8E8C7FFC-61BC-4EC8-B585-066A62D1097E}">
+    <dsp:sp modelId="{8694ED8D-E215-4D76-857D-83338FC1B4B1}">
       <dsp:nvSpPr>
         <dsp:cNvPr id="0" name=""/>
         <dsp:cNvSpPr/>
       </dsp:nvSpPr>
       <dsp:spPr>
         <a:xfrm>
-          <a:off x="0" y="93698"/>
-          <a:ext cx="10504557" cy="540540"/>
+          <a:off x="0" y="571869"/>
+          <a:ext cx="10504557" cy="737099"/>
         </a:xfrm>
         <a:prstGeom prst="roundRect">
           <a:avLst/>
@@ -1625,12 +1457,12 @@
         </a:fontRef>
       </dsp:style>
       <dsp:txBody>
-        <a:bodyPr spcFirstLastPara="0" vert="horz" wrap="square" lIns="83820" tIns="83820" rIns="83820" bIns="83820" numCol="1" spcCol="1270" anchor="ctr" anchorCtr="0">
+        <a:bodyPr spcFirstLastPara="0" vert="horz" wrap="square" lIns="114300" tIns="114300" rIns="114300" bIns="114300" numCol="1" spcCol="1270" anchor="ctr" anchorCtr="0">
           <a:noAutofit/>
         </a:bodyPr>
         <a:lstStyle/>
         <a:p>
-          <a:pPr marL="0" lvl="0" indent="0" algn="l" defTabSz="977900">
+          <a:pPr marL="0" lvl="0" indent="0" algn="l" defTabSz="1333500">
             <a:lnSpc>
               <a:spcPct val="90000"/>
             </a:lnSpc>
@@ -1643,7 +1475,7 @@
             <a:buNone/>
           </a:pPr>
           <a:r>
-            <a:rPr lang="en-US" sz="2200" kern="1200" dirty="0">
+            <a:rPr lang="en-US" sz="3000" kern="1200" dirty="0">
               <a:solidFill>
                 <a:srgbClr val="FFFFFF"/>
               </a:solidFill>
@@ -1651,24 +1483,24 @@
               <a:ea typeface="+mn-ea"/>
               <a:cs typeface="+mn-cs"/>
             </a:rPr>
-            <a:t>docs/ARCHITECTURE.md (1–2 pages; simple diagram + explanation)</a:t>
+            <a:t>docs/sprints/W03/plan.md</a:t>
           </a:r>
         </a:p>
       </dsp:txBody>
       <dsp:txXfrm>
-        <a:off x="26387" y="120085"/>
-        <a:ext cx="10451783" cy="487766"/>
+        <a:off x="35982" y="607851"/>
+        <a:ext cx="10432593" cy="665135"/>
       </dsp:txXfrm>
     </dsp:sp>
-    <dsp:sp modelId="{8694ED8D-E215-4D76-857D-83338FC1B4B1}">
+    <dsp:sp modelId="{6D8FE49D-26DA-4425-8C7E-DCE94839AD71}">
       <dsp:nvSpPr>
         <dsp:cNvPr id="0" name=""/>
         <dsp:cNvSpPr/>
       </dsp:nvSpPr>
       <dsp:spPr>
         <a:xfrm>
-          <a:off x="0" y="697598"/>
-          <a:ext cx="10504557" cy="540540"/>
+          <a:off x="0" y="1395369"/>
+          <a:ext cx="10504557" cy="737099"/>
         </a:xfrm>
         <a:prstGeom prst="roundRect">
           <a:avLst/>
@@ -1737,12 +1569,12 @@
         </a:fontRef>
       </dsp:style>
       <dsp:txBody>
-        <a:bodyPr spcFirstLastPara="0" vert="horz" wrap="square" lIns="83820" tIns="83820" rIns="83820" bIns="83820" numCol="1" spcCol="1270" anchor="ctr" anchorCtr="0">
+        <a:bodyPr spcFirstLastPara="0" vert="horz" wrap="square" lIns="114300" tIns="114300" rIns="114300" bIns="114300" numCol="1" spcCol="1270" anchor="ctr" anchorCtr="0">
           <a:noAutofit/>
         </a:bodyPr>
         <a:lstStyle/>
         <a:p>
-          <a:pPr marL="0" lvl="0" indent="0" algn="l" defTabSz="977900">
+          <a:pPr marL="0" lvl="0" indent="0" algn="l" defTabSz="1333500">
             <a:lnSpc>
               <a:spcPct val="90000"/>
             </a:lnSpc>
@@ -1755,7 +1587,7 @@
             <a:buNone/>
           </a:pPr>
           <a:r>
-            <a:rPr lang="en-US" sz="2200" kern="1200">
+            <a:rPr lang="en-US" sz="3000" b="1" kern="1200" dirty="0">
               <a:solidFill>
                 <a:srgbClr val="FFFFFF"/>
               </a:solidFill>
@@ -1763,24 +1595,35 @@
               <a:ea typeface="+mn-ea"/>
               <a:cs typeface="+mn-cs"/>
             </a:rPr>
-            <a:t>docs/sprints/W01/plan.md</a:t>
+            <a:t> </a:t>
+          </a:r>
+          <a:r>
+            <a:rPr lang="en-US" sz="3000" kern="1200" dirty="0">
+              <a:solidFill>
+                <a:srgbClr val="FFFFFF"/>
+              </a:solidFill>
+              <a:latin typeface="Aptos" panose="02110004020202020204"/>
+              <a:ea typeface="+mn-ea"/>
+              <a:cs typeface="+mn-cs"/>
+            </a:rPr>
+            <a:t>examples/00_sdk_smoke.py</a:t>
           </a:r>
         </a:p>
       </dsp:txBody>
       <dsp:txXfrm>
-        <a:off x="26387" y="723985"/>
-        <a:ext cx="10451783" cy="487766"/>
+        <a:off x="35982" y="1431351"/>
+        <a:ext cx="10432593" cy="665135"/>
       </dsp:txXfrm>
     </dsp:sp>
-    <dsp:sp modelId="{6D8FE49D-26DA-4425-8C7E-DCE94839AD71}">
+    <dsp:sp modelId="{09E87734-5520-49F9-A61A-7BFE46AABF34}">
       <dsp:nvSpPr>
         <dsp:cNvPr id="0" name=""/>
         <dsp:cNvSpPr/>
       </dsp:nvSpPr>
       <dsp:spPr>
         <a:xfrm>
-          <a:off x="0" y="1301499"/>
-          <a:ext cx="10504557" cy="540540"/>
+          <a:off x="0" y="2218869"/>
+          <a:ext cx="10504557" cy="737099"/>
         </a:xfrm>
         <a:prstGeom prst="roundRect">
           <a:avLst/>
@@ -1849,12 +1692,12 @@
         </a:fontRef>
       </dsp:style>
       <dsp:txBody>
-        <a:bodyPr spcFirstLastPara="0" vert="horz" wrap="square" lIns="83820" tIns="83820" rIns="83820" bIns="83820" numCol="1" spcCol="1270" anchor="ctr" anchorCtr="0">
+        <a:bodyPr spcFirstLastPara="0" vert="horz" wrap="square" lIns="114300" tIns="114300" rIns="114300" bIns="114300" numCol="1" spcCol="1270" anchor="ctr" anchorCtr="0">
           <a:noAutofit/>
         </a:bodyPr>
         <a:lstStyle/>
         <a:p>
-          <a:pPr marL="0" lvl="0" indent="0" algn="l" defTabSz="977900">
+          <a:pPr marL="0" lvl="0" indent="0" algn="l" defTabSz="1333500">
             <a:lnSpc>
               <a:spcPct val="90000"/>
             </a:lnSpc>
@@ -1867,7 +1710,7 @@
             <a:buNone/>
           </a:pPr>
           <a:r>
-            <a:rPr lang="en-US" sz="2200" b="1" kern="1200">
+            <a:rPr lang="en-US" sz="3000" kern="1200" dirty="0">
               <a:solidFill>
                 <a:srgbClr val="FFFFFF"/>
               </a:solidFill>
@@ -1875,10 +1718,10 @@
               <a:ea typeface="+mn-ea"/>
               <a:cs typeface="+mn-cs"/>
             </a:rPr>
-            <a:t> </a:t>
+            <a:t>3d Drone </a:t>
           </a:r>
           <a:r>
-            <a:rPr lang="en-US" sz="2200" kern="1200">
+            <a:rPr lang="en-US" sz="3000" kern="1200" dirty="0" err="1">
               <a:solidFill>
                 <a:srgbClr val="FFFFFF"/>
               </a:solidFill>
@@ -1886,24 +1729,35 @@
               <a:ea typeface="+mn-ea"/>
               <a:cs typeface="+mn-cs"/>
             </a:rPr>
-            <a:t>examples/00_sdk_smoke.py</a:t>
+            <a:t>Drone</a:t>
+          </a:r>
+          <a:r>
+            <a:rPr lang="en-US" sz="3000" kern="1200" dirty="0">
+              <a:solidFill>
+                <a:srgbClr val="FFFFFF"/>
+              </a:solidFill>
+              <a:latin typeface="Aptos" panose="02110004020202020204"/>
+              <a:ea typeface="+mn-ea"/>
+              <a:cs typeface="+mn-cs"/>
+            </a:rPr>
+            <a:t> Model inside Project</a:t>
           </a:r>
         </a:p>
       </dsp:txBody>
       <dsp:txXfrm>
-        <a:off x="26387" y="1327886"/>
-        <a:ext cx="10451783" cy="487766"/>
+        <a:off x="35982" y="2254851"/>
+        <a:ext cx="10432593" cy="665135"/>
       </dsp:txXfrm>
     </dsp:sp>
-    <dsp:sp modelId="{09E87734-5520-49F9-A61A-7BFE46AABF34}">
+    <dsp:sp modelId="{8668C22C-39F1-4F13-A3C8-96243DD7C753}">
       <dsp:nvSpPr>
         <dsp:cNvPr id="0" name=""/>
         <dsp:cNvSpPr/>
       </dsp:nvSpPr>
       <dsp:spPr>
         <a:xfrm>
-          <a:off x="0" y="1905399"/>
-          <a:ext cx="10504557" cy="540540"/>
+          <a:off x="0" y="3042369"/>
+          <a:ext cx="10504557" cy="737099"/>
         </a:xfrm>
         <a:prstGeom prst="roundRect">
           <a:avLst/>
@@ -1972,12 +1826,12 @@
         </a:fontRef>
       </dsp:style>
       <dsp:txBody>
-        <a:bodyPr spcFirstLastPara="0" vert="horz" wrap="square" lIns="83820" tIns="83820" rIns="83820" bIns="83820" numCol="1" spcCol="1270" anchor="ctr" anchorCtr="0">
+        <a:bodyPr spcFirstLastPara="0" vert="horz" wrap="square" lIns="114300" tIns="114300" rIns="114300" bIns="114300" numCol="1" spcCol="1270" anchor="ctr" anchorCtr="0">
           <a:noAutofit/>
         </a:bodyPr>
         <a:lstStyle/>
         <a:p>
-          <a:pPr marL="0" lvl="0" indent="0" algn="l" defTabSz="977900">
+          <a:pPr marL="0" lvl="0" indent="0" algn="l" defTabSz="1333500">
             <a:lnSpc>
               <a:spcPct val="90000"/>
             </a:lnSpc>
@@ -1990,119 +1844,7 @@
             <a:buNone/>
           </a:pPr>
           <a:r>
-            <a:rPr lang="en-US" sz="2200" kern="1200">
-              <a:solidFill>
-                <a:srgbClr val="FFFFFF"/>
-              </a:solidFill>
-              <a:latin typeface="Aptos" panose="02110004020202020204"/>
-              <a:ea typeface="+mn-ea"/>
-              <a:cs typeface="+mn-cs"/>
-            </a:rPr>
-            <a:t>sdk/tests/test_import.py </a:t>
-          </a:r>
-        </a:p>
-      </dsp:txBody>
-      <dsp:txXfrm>
-        <a:off x="26387" y="1931786"/>
-        <a:ext cx="10451783" cy="487766"/>
-      </dsp:txXfrm>
-    </dsp:sp>
-    <dsp:sp modelId="{8668C22C-39F1-4F13-A3C8-96243DD7C753}">
-      <dsp:nvSpPr>
-        <dsp:cNvPr id="0" name=""/>
-        <dsp:cNvSpPr/>
-      </dsp:nvSpPr>
-      <dsp:spPr>
-        <a:xfrm>
-          <a:off x="0" y="2509299"/>
-          <a:ext cx="10504557" cy="540540"/>
-        </a:xfrm>
-        <a:prstGeom prst="roundRect">
-          <a:avLst/>
-        </a:prstGeom>
-        <a:gradFill rotWithShape="0">
-          <a:gsLst>
-            <a:gs pos="0">
-              <a:schemeClr val="accent6">
-                <a:hueOff val="0"/>
-                <a:satOff val="0"/>
-                <a:lumOff val="0"/>
-                <a:alphaOff val="0"/>
-                <a:satMod val="103000"/>
-                <a:lumMod val="102000"/>
-                <a:tint val="94000"/>
-              </a:schemeClr>
-            </a:gs>
-            <a:gs pos="50000">
-              <a:schemeClr val="accent6">
-                <a:hueOff val="0"/>
-                <a:satOff val="0"/>
-                <a:lumOff val="0"/>
-                <a:alphaOff val="0"/>
-                <a:satMod val="110000"/>
-                <a:lumMod val="100000"/>
-                <a:shade val="100000"/>
-              </a:schemeClr>
-            </a:gs>
-            <a:gs pos="100000">
-              <a:schemeClr val="accent6">
-                <a:hueOff val="0"/>
-                <a:satOff val="0"/>
-                <a:lumOff val="0"/>
-                <a:alphaOff val="0"/>
-                <a:lumMod val="99000"/>
-                <a:satMod val="120000"/>
-                <a:shade val="78000"/>
-              </a:schemeClr>
-            </a:gs>
-          </a:gsLst>
-          <a:lin ang="5400000" scaled="0"/>
-        </a:gradFill>
-        <a:ln>
-          <a:noFill/>
-        </a:ln>
-        <a:effectLst>
-          <a:outerShdw blurRad="57150" dist="19050" dir="5400000" algn="ctr" rotWithShape="0">
-            <a:srgbClr val="000000">
-              <a:alpha val="63000"/>
-            </a:srgbClr>
-          </a:outerShdw>
-        </a:effectLst>
-      </dsp:spPr>
-      <dsp:style>
-        <a:lnRef idx="0">
-          <a:scrgbClr r="0" g="0" b="0"/>
-        </a:lnRef>
-        <a:fillRef idx="3">
-          <a:scrgbClr r="0" g="0" b="0"/>
-        </a:fillRef>
-        <a:effectRef idx="3">
-          <a:scrgbClr r="0" g="0" b="0"/>
-        </a:effectRef>
-        <a:fontRef idx="minor">
-          <a:schemeClr val="lt1"/>
-        </a:fontRef>
-      </dsp:style>
-      <dsp:txBody>
-        <a:bodyPr spcFirstLastPara="0" vert="horz" wrap="square" lIns="83820" tIns="83820" rIns="83820" bIns="83820" numCol="1" spcCol="1270" anchor="ctr" anchorCtr="0">
-          <a:noAutofit/>
-        </a:bodyPr>
-        <a:lstStyle/>
-        <a:p>
-          <a:pPr marL="0" lvl="0" indent="0" algn="l" defTabSz="977900">
-            <a:lnSpc>
-              <a:spcPct val="90000"/>
-            </a:lnSpc>
-            <a:spcBef>
-              <a:spcPct val="0"/>
-            </a:spcBef>
-            <a:spcAft>
-              <a:spcPct val="35000"/>
-            </a:spcAft>
-            <a:buNone/>
-          </a:pPr>
-          <a:r>
-            <a:rPr lang="en-US" sz="2200" kern="1200">
+            <a:rPr lang="en-US" sz="3000" kern="1200" dirty="0">
               <a:solidFill>
                 <a:srgbClr val="FFFFFF"/>
               </a:solidFill>
@@ -2112,7 +1854,7 @@
             </a:rPr>
             <a:t>docs/PROTOCOL.md (updated to match implemented messages)</a:t>
           </a:r>
-          <a:endParaRPr lang="en-US" sz="2200" kern="1200">
+          <a:endParaRPr lang="en-US" sz="3000" kern="1200" dirty="0">
             <a:solidFill>
               <a:srgbClr val="FFFFFF"/>
             </a:solidFill>
@@ -2123,232 +1865,8 @@
         </a:p>
       </dsp:txBody>
       <dsp:txXfrm>
-        <a:off x="26387" y="2535686"/>
-        <a:ext cx="10451783" cy="487766"/>
-      </dsp:txXfrm>
-    </dsp:sp>
-    <dsp:sp modelId="{A3559C65-4E5D-4CA8-85BC-C432C3837387}">
-      <dsp:nvSpPr>
-        <dsp:cNvPr id="0" name=""/>
-        <dsp:cNvSpPr/>
-      </dsp:nvSpPr>
-      <dsp:spPr>
-        <a:xfrm>
-          <a:off x="0" y="3113199"/>
-          <a:ext cx="10504557" cy="540540"/>
-        </a:xfrm>
-        <a:prstGeom prst="roundRect">
-          <a:avLst/>
-        </a:prstGeom>
-        <a:gradFill rotWithShape="0">
-          <a:gsLst>
-            <a:gs pos="0">
-              <a:schemeClr val="accent2">
-                <a:hueOff val="0"/>
-                <a:satOff val="0"/>
-                <a:lumOff val="0"/>
-                <a:alphaOff val="0"/>
-                <a:satMod val="103000"/>
-                <a:lumMod val="102000"/>
-                <a:tint val="94000"/>
-              </a:schemeClr>
-            </a:gs>
-            <a:gs pos="50000">
-              <a:schemeClr val="accent2">
-                <a:hueOff val="0"/>
-                <a:satOff val="0"/>
-                <a:lumOff val="0"/>
-                <a:alphaOff val="0"/>
-                <a:satMod val="110000"/>
-                <a:lumMod val="100000"/>
-                <a:shade val="100000"/>
-              </a:schemeClr>
-            </a:gs>
-            <a:gs pos="100000">
-              <a:schemeClr val="accent2">
-                <a:hueOff val="0"/>
-                <a:satOff val="0"/>
-                <a:lumOff val="0"/>
-                <a:alphaOff val="0"/>
-                <a:lumMod val="99000"/>
-                <a:satMod val="120000"/>
-                <a:shade val="78000"/>
-              </a:schemeClr>
-            </a:gs>
-          </a:gsLst>
-          <a:lin ang="5400000" scaled="0"/>
-        </a:gradFill>
-        <a:ln>
-          <a:noFill/>
-        </a:ln>
-        <a:effectLst>
-          <a:outerShdw blurRad="57150" dist="19050" dir="5400000" algn="ctr" rotWithShape="0">
-            <a:srgbClr val="000000">
-              <a:alpha val="63000"/>
-            </a:srgbClr>
-          </a:outerShdw>
-        </a:effectLst>
-      </dsp:spPr>
-      <dsp:style>
-        <a:lnRef idx="0">
-          <a:scrgbClr r="0" g="0" b="0"/>
-        </a:lnRef>
-        <a:fillRef idx="3">
-          <a:scrgbClr r="0" g="0" b="0"/>
-        </a:fillRef>
-        <a:effectRef idx="3">
-          <a:scrgbClr r="0" g="0" b="0"/>
-        </a:effectRef>
-        <a:fontRef idx="minor">
-          <a:schemeClr val="lt1"/>
-        </a:fontRef>
-      </dsp:style>
-      <dsp:txBody>
-        <a:bodyPr spcFirstLastPara="0" vert="horz" wrap="square" lIns="83820" tIns="83820" rIns="83820" bIns="83820" numCol="1" spcCol="1270" anchor="ctr" anchorCtr="0">
-          <a:noAutofit/>
-        </a:bodyPr>
-        <a:lstStyle/>
-        <a:p>
-          <a:pPr marL="0" lvl="0" indent="0" algn="l" defTabSz="977900" rtl="0">
-            <a:lnSpc>
-              <a:spcPct val="90000"/>
-            </a:lnSpc>
-            <a:spcBef>
-              <a:spcPct val="0"/>
-            </a:spcBef>
-            <a:spcAft>
-              <a:spcPct val="35000"/>
-            </a:spcAft>
-            <a:buNone/>
-          </a:pPr>
-          <a:r>
-            <a:rPr lang="en-US" sz="2200" kern="1200">
-              <a:solidFill>
-                <a:srgbClr val="FFFFFF"/>
-              </a:solidFill>
-              <a:latin typeface="Calibri"/>
-              <a:ea typeface="Calibri"/>
-              <a:cs typeface="Calibri"/>
-            </a:rPr>
-            <a:t>Docs/sprints/W02/plan.md</a:t>
-          </a:r>
-        </a:p>
-      </dsp:txBody>
-      <dsp:txXfrm>
-        <a:off x="26387" y="3139586"/>
-        <a:ext cx="10451783" cy="487766"/>
-      </dsp:txXfrm>
-    </dsp:sp>
-    <dsp:sp modelId="{7F0D6C25-7930-47AB-8FBA-CE4FDF55D586}">
-      <dsp:nvSpPr>
-        <dsp:cNvPr id="0" name=""/>
-        <dsp:cNvSpPr/>
-      </dsp:nvSpPr>
-      <dsp:spPr>
-        <a:xfrm>
-          <a:off x="0" y="3717099"/>
-          <a:ext cx="10504557" cy="540540"/>
-        </a:xfrm>
-        <a:prstGeom prst="roundRect">
-          <a:avLst/>
-        </a:prstGeom>
-        <a:gradFill rotWithShape="0">
-          <a:gsLst>
-            <a:gs pos="0">
-              <a:schemeClr val="accent3">
-                <a:hueOff val="0"/>
-                <a:satOff val="0"/>
-                <a:lumOff val="0"/>
-                <a:alphaOff val="0"/>
-                <a:satMod val="103000"/>
-                <a:lumMod val="102000"/>
-                <a:tint val="94000"/>
-              </a:schemeClr>
-            </a:gs>
-            <a:gs pos="50000">
-              <a:schemeClr val="accent3">
-                <a:hueOff val="0"/>
-                <a:satOff val="0"/>
-                <a:lumOff val="0"/>
-                <a:alphaOff val="0"/>
-                <a:satMod val="110000"/>
-                <a:lumMod val="100000"/>
-                <a:shade val="100000"/>
-              </a:schemeClr>
-            </a:gs>
-            <a:gs pos="100000">
-              <a:schemeClr val="accent3">
-                <a:hueOff val="0"/>
-                <a:satOff val="0"/>
-                <a:lumOff val="0"/>
-                <a:alphaOff val="0"/>
-                <a:lumMod val="99000"/>
-                <a:satMod val="120000"/>
-                <a:shade val="78000"/>
-              </a:schemeClr>
-            </a:gs>
-          </a:gsLst>
-          <a:lin ang="5400000" scaled="0"/>
-        </a:gradFill>
-        <a:ln>
-          <a:noFill/>
-        </a:ln>
-        <a:effectLst>
-          <a:outerShdw blurRad="57150" dist="19050" dir="5400000" algn="ctr" rotWithShape="0">
-            <a:srgbClr val="000000">
-              <a:alpha val="63000"/>
-            </a:srgbClr>
-          </a:outerShdw>
-        </a:effectLst>
-      </dsp:spPr>
-      <dsp:style>
-        <a:lnRef idx="0">
-          <a:scrgbClr r="0" g="0" b="0"/>
-        </a:lnRef>
-        <a:fillRef idx="3">
-          <a:scrgbClr r="0" g="0" b="0"/>
-        </a:fillRef>
-        <a:effectRef idx="3">
-          <a:scrgbClr r="0" g="0" b="0"/>
-        </a:effectRef>
-        <a:fontRef idx="minor">
-          <a:schemeClr val="lt1"/>
-        </a:fontRef>
-      </dsp:style>
-      <dsp:txBody>
-        <a:bodyPr spcFirstLastPara="0" vert="horz" wrap="square" lIns="83820" tIns="83820" rIns="83820" bIns="83820" numCol="1" spcCol="1270" anchor="ctr" anchorCtr="0">
-          <a:noAutofit/>
-        </a:bodyPr>
-        <a:lstStyle/>
-        <a:p>
-          <a:pPr marL="0" lvl="0" indent="0" algn="l" defTabSz="977900" rtl="0">
-            <a:lnSpc>
-              <a:spcPct val="90000"/>
-            </a:lnSpc>
-            <a:spcBef>
-              <a:spcPct val="0"/>
-            </a:spcBef>
-            <a:spcAft>
-              <a:spcPct val="35000"/>
-            </a:spcAft>
-            <a:buNone/>
-          </a:pPr>
-          <a:r>
-            <a:rPr lang="en-US" sz="2200" kern="1200">
-              <a:solidFill>
-                <a:srgbClr val="FFFFFF"/>
-              </a:solidFill>
-              <a:latin typeface="Calibri"/>
-              <a:ea typeface="Calibri"/>
-              <a:cs typeface="Calibri"/>
-            </a:rPr>
-            <a:t>docs/presentations/W02.pdf (or W02.pptx)</a:t>
-          </a:r>
-        </a:p>
-      </dsp:txBody>
-      <dsp:txXfrm>
-        <a:off x="26387" y="3743486"/>
-        <a:ext cx="10451783" cy="487766"/>
+        <a:off x="35982" y="3078351"/>
+        <a:ext cx="10432593" cy="665135"/>
       </dsp:txXfrm>
     </dsp:sp>
   </dsp:spTree>
@@ -3703,7 +3221,7 @@
           <a:p>
             <a:fld id="{FD11E731-7C35-4F3A-86C7-28C15E898D8A}" type="datetimeFigureOut">
               <a:rPr lang="en-US" smtClean="0"/>
-              <a:t>2/28/2026</a:t>
+              <a:t>3/5/2026</a:t>
             </a:fld>
             <a:endParaRPr lang="en-US"/>
           </a:p>
@@ -3901,7 +3419,7 @@
           <a:p>
             <a:fld id="{FD11E731-7C35-4F3A-86C7-28C15E898D8A}" type="datetimeFigureOut">
               <a:rPr lang="en-US" smtClean="0"/>
-              <a:t>3/1/2026</a:t>
+              <a:t>3/5/2026</a:t>
             </a:fld>
             <a:endParaRPr lang="en-US"/>
           </a:p>
@@ -4109,7 +3627,7 @@
           <a:p>
             <a:fld id="{FD11E731-7C35-4F3A-86C7-28C15E898D8A}" type="datetimeFigureOut">
               <a:rPr lang="en-US" smtClean="0"/>
-              <a:t>3/1/2026</a:t>
+              <a:t>3/5/2026</a:t>
             </a:fld>
             <a:endParaRPr lang="en-US"/>
           </a:p>
@@ -4307,7 +3825,7 @@
           <a:p>
             <a:fld id="{FD11E731-7C35-4F3A-86C7-28C15E898D8A}" type="datetimeFigureOut">
               <a:rPr lang="en-US" smtClean="0"/>
-              <a:t>2/28/2026</a:t>
+              <a:t>3/5/2026</a:t>
             </a:fld>
             <a:endParaRPr lang="en-US"/>
           </a:p>
@@ -4582,7 +4100,7 @@
           <a:p>
             <a:fld id="{FD11E731-7C35-4F3A-86C7-28C15E898D8A}" type="datetimeFigureOut">
               <a:rPr lang="en-US" smtClean="0"/>
-              <a:t>3/1/2026</a:t>
+              <a:t>3/5/2026</a:t>
             </a:fld>
             <a:endParaRPr lang="en-US"/>
           </a:p>
@@ -4847,7 +4365,7 @@
           <a:p>
             <a:fld id="{FD11E731-7C35-4F3A-86C7-28C15E898D8A}" type="datetimeFigureOut">
               <a:rPr lang="en-US" smtClean="0"/>
-              <a:t>3/1/2026</a:t>
+              <a:t>3/5/2026</a:t>
             </a:fld>
             <a:endParaRPr lang="en-US"/>
           </a:p>
@@ -5259,7 +4777,7 @@
           <a:p>
             <a:fld id="{FD11E731-7C35-4F3A-86C7-28C15E898D8A}" type="datetimeFigureOut">
               <a:rPr lang="en-US" smtClean="0"/>
-              <a:t>3/1/2026</a:t>
+              <a:t>3/5/2026</a:t>
             </a:fld>
             <a:endParaRPr lang="en-US"/>
           </a:p>
@@ -5400,7 +4918,7 @@
           <a:p>
             <a:fld id="{FD11E731-7C35-4F3A-86C7-28C15E898D8A}" type="datetimeFigureOut">
               <a:rPr lang="en-US" smtClean="0"/>
-              <a:t>3/1/2026</a:t>
+              <a:t>3/5/2026</a:t>
             </a:fld>
             <a:endParaRPr lang="en-US"/>
           </a:p>
@@ -5513,7 +5031,7 @@
           <a:p>
             <a:fld id="{FD11E731-7C35-4F3A-86C7-28C15E898D8A}" type="datetimeFigureOut">
               <a:rPr lang="en-US" smtClean="0"/>
-              <a:t>3/1/2026</a:t>
+              <a:t>3/5/2026</a:t>
             </a:fld>
             <a:endParaRPr lang="en-US"/>
           </a:p>
@@ -5824,7 +5342,7 @@
           <a:p>
             <a:fld id="{FD11E731-7C35-4F3A-86C7-28C15E898D8A}" type="datetimeFigureOut">
               <a:rPr lang="en-US" smtClean="0"/>
-              <a:t>3/1/2026</a:t>
+              <a:t>3/5/2026</a:t>
             </a:fld>
             <a:endParaRPr lang="en-US"/>
           </a:p>
@@ -6112,7 +5630,7 @@
           <a:p>
             <a:fld id="{FD11E731-7C35-4F3A-86C7-28C15E898D8A}" type="datetimeFigureOut">
               <a:rPr lang="en-US" smtClean="0"/>
-              <a:t>3/1/2026</a:t>
+              <a:t>3/5/2026</a:t>
             </a:fld>
             <a:endParaRPr lang="en-US"/>
           </a:p>
@@ -6353,7 +5871,7 @@
           <a:p>
             <a:fld id="{FD11E731-7C35-4F3A-86C7-28C15E898D8A}" type="datetimeFigureOut">
               <a:rPr lang="en-US" smtClean="0"/>
-              <a:t>2/28/2026</a:t>
+              <a:t>3/5/2026</a:t>
             </a:fld>
             <a:endParaRPr lang="en-US"/>
           </a:p>
@@ -7502,424 +7020,6 @@
           <a:chExt cx="0" cy="0"/>
         </a:xfrm>
       </p:grpSpPr>
-      <p:pic>
-        <p:nvPicPr>
-          <p:cNvPr id="15" name="Picture 14">
-            <a:extLst>
-              <a:ext uri="{FF2B5EF4-FFF2-40B4-BE49-F238E27FC236}">
-                <a16:creationId xmlns:a16="http://schemas.microsoft.com/office/drawing/2014/main" id="{A9153D83-57A3-FC68-CC82-358139BB4C0D}"/>
-              </a:ext>
-            </a:extLst>
-          </p:cNvPr>
-          <p:cNvPicPr>
-            <a:picLocks noChangeAspect="1"/>
-          </p:cNvPicPr>
-          <p:nvPr/>
-        </p:nvPicPr>
-        <p:blipFill>
-          <a:blip r:embed="rId2">
-            <a:duotone>
-              <a:schemeClr val="bg2">
-                <a:shade val="45000"/>
-                <a:satMod val="135000"/>
-              </a:schemeClr>
-              <a:prstClr val="white"/>
-            </a:duotone>
-          </a:blip>
-          <a:srcRect t="11637" r="9091" b="37227"/>
-          <a:stretch>
-            <a:fillRect/>
-          </a:stretch>
-        </p:blipFill>
-        <p:spPr>
-          <a:xfrm>
-            <a:off x="-38090" y="10"/>
-            <a:ext cx="12191980" cy="6857990"/>
-          </a:xfrm>
-          <a:prstGeom prst="rect">
-            <a:avLst/>
-          </a:prstGeom>
-        </p:spPr>
-      </p:pic>
-      <p:sp>
-        <p:nvSpPr>
-          <p:cNvPr id="24" name="Rectangle 23">
-            <a:extLst>
-              <a:ext uri="{FF2B5EF4-FFF2-40B4-BE49-F238E27FC236}">
-                <a16:creationId xmlns:a16="http://schemas.microsoft.com/office/drawing/2014/main" id="{B50AB553-2A96-4A92-96F2-93548E096954}"/>
-              </a:ext>
-              <a:ext uri="{C183D7F6-B498-43B3-948B-1728B52AA6E4}">
-                <adec:decorative xmlns:adec="http://schemas.microsoft.com/office/drawing/2017/decorative" val="1"/>
-              </a:ext>
-            </a:extLst>
-          </p:cNvPr>
-          <p:cNvSpPr>
-            <a:spLocks noGrp="1" noRot="1" noChangeAspect="1" noMove="1" noResize="1" noEditPoints="1" noAdjustHandles="1" noChangeArrowheads="1" noChangeShapeType="1" noTextEdit="1"/>
-          </p:cNvSpPr>
-          <p:nvPr>
-            <p:extLst>
-              <p:ext uri="{386F3935-93C4-4BCD-93E2-E3B085C9AB24}">
-                <p16:designElem xmlns:p16="http://schemas.microsoft.com/office/powerpoint/2015/main" val="1"/>
-              </p:ext>
-            </p:extLst>
-          </p:nvPr>
-        </p:nvSpPr>
-        <p:spPr>
-          <a:xfrm>
-            <a:off x="0" y="0"/>
-            <a:ext cx="12192000" cy="6858000"/>
-          </a:xfrm>
-          <a:prstGeom prst="rect">
-            <a:avLst/>
-          </a:prstGeom>
-          <a:gradFill>
-            <a:gsLst>
-              <a:gs pos="10000">
-                <a:schemeClr val="bg2">
-                  <a:alpha val="68000"/>
-                </a:schemeClr>
-              </a:gs>
-              <a:gs pos="85000">
-                <a:schemeClr val="bg2">
-                  <a:alpha val="97000"/>
-                </a:schemeClr>
-              </a:gs>
-            </a:gsLst>
-            <a:path path="circle">
-              <a:fillToRect l="50000" t="50000" r="50000" b="50000"/>
-            </a:path>
-          </a:gradFill>
-          <a:ln>
-            <a:noFill/>
-          </a:ln>
-        </p:spPr>
-        <p:style>
-          <a:lnRef idx="2">
-            <a:schemeClr val="accent1">
-              <a:shade val="50000"/>
-            </a:schemeClr>
-          </a:lnRef>
-          <a:fillRef idx="1">
-            <a:schemeClr val="accent1"/>
-          </a:fillRef>
-          <a:effectRef idx="0">
-            <a:schemeClr val="accent1"/>
-          </a:effectRef>
-          <a:fontRef idx="minor">
-            <a:schemeClr val="lt1"/>
-          </a:fontRef>
-        </p:style>
-        <p:txBody>
-          <a:bodyPr rtlCol="0" anchor="ctr"/>
-          <a:lstStyle/>
-          <a:p>
-            <a:pPr algn="ctr"/>
-            <a:endParaRPr lang="en-US"/>
-          </a:p>
-        </p:txBody>
-      </p:sp>
-      <p:sp>
-        <p:nvSpPr>
-          <p:cNvPr id="2" name="Title 1">
-            <a:extLst>
-              <a:ext uri="{FF2B5EF4-FFF2-40B4-BE49-F238E27FC236}">
-                <a16:creationId xmlns:a16="http://schemas.microsoft.com/office/drawing/2014/main" id="{2D7AF4BD-C9E6-DD9E-8AD0-9DAD0F65147F}"/>
-              </a:ext>
-            </a:extLst>
-          </p:cNvPr>
-          <p:cNvSpPr>
-            <a:spLocks noGrp="1"/>
-          </p:cNvSpPr>
-          <p:nvPr>
-            <p:ph type="title"/>
-          </p:nvPr>
-        </p:nvSpPr>
-        <p:spPr>
-          <a:xfrm>
-            <a:off x="838200" y="365125"/>
-            <a:ext cx="10515600" cy="1325563"/>
-          </a:xfrm>
-        </p:spPr>
-        <p:txBody>
-          <a:bodyPr>
-            <a:normAutofit/>
-          </a:bodyPr>
-          <a:lstStyle/>
-          <a:p>
-            <a:r>
-              <a:rPr lang="en-US"/>
-              <a:t>Deliverables</a:t>
-            </a:r>
-          </a:p>
-        </p:txBody>
-      </p:sp>
-      <p:graphicFrame>
-        <p:nvGraphicFramePr>
-          <p:cNvPr id="14" name="Content Placeholder 2">
-            <a:extLst>
-              <a:ext uri="{FF2B5EF4-FFF2-40B4-BE49-F238E27FC236}">
-                <a16:creationId xmlns:a16="http://schemas.microsoft.com/office/drawing/2014/main" id="{CB9FB94D-28CA-B8AF-E99E-B55D35733884}"/>
-              </a:ext>
-            </a:extLst>
-          </p:cNvPr>
-          <p:cNvGraphicFramePr>
-            <a:graphicFrameLocks noGrp="1"/>
-          </p:cNvGraphicFramePr>
-          <p:nvPr>
-            <p:ph idx="1"/>
-            <p:extLst>
-              <p:ext uri="{D42A27DB-BD31-4B8C-83A1-F6EECF244321}">
-                <p14:modId xmlns:p14="http://schemas.microsoft.com/office/powerpoint/2010/main" val="2308325228"/>
-              </p:ext>
-            </p:extLst>
-          </p:nvPr>
-        </p:nvGraphicFramePr>
-        <p:xfrm>
-          <a:off x="805068" y="1648929"/>
-          <a:ext cx="10504557" cy="4351338"/>
-        </p:xfrm>
-        <a:graphic>
-          <a:graphicData uri="http://schemas.openxmlformats.org/drawingml/2006/diagram">
-            <dgm:relIds xmlns:dgm="http://schemas.openxmlformats.org/drawingml/2006/diagram" xmlns:r="http://schemas.openxmlformats.org/officeDocument/2006/relationships" r:dm="rId3" r:lo="rId4" r:qs="rId5" r:cs="rId6"/>
-          </a:graphicData>
-        </a:graphic>
-      </p:graphicFrame>
-      <p:pic>
-        <p:nvPicPr>
-          <p:cNvPr id="16" name="Graphic 15" descr="Checkbox Checked with solid fill">
-            <a:extLst>
-              <a:ext uri="{FF2B5EF4-FFF2-40B4-BE49-F238E27FC236}">
-                <a16:creationId xmlns:a16="http://schemas.microsoft.com/office/drawing/2014/main" id="{A3966D21-1CF3-1D43-40D9-98B7748A504A}"/>
-              </a:ext>
-            </a:extLst>
-          </p:cNvPr>
-          <p:cNvPicPr>
-            <a:picLocks noChangeAspect="1"/>
-          </p:cNvPicPr>
-          <p:nvPr/>
-        </p:nvPicPr>
-        <p:blipFill>
-          <a:blip r:embed="rId8">
-            <a:extLst>
-              <a:ext uri="{96DAC541-7B7A-43D3-8B79-37D633B846F1}">
-                <asvg:svgBlip xmlns:asvg="http://schemas.microsoft.com/office/drawing/2016/SVG/main" r:embed="rId9"/>
-              </a:ext>
-            </a:extLst>
-          </a:blip>
-          <a:stretch>
-            <a:fillRect/>
-          </a:stretch>
-        </p:blipFill>
-        <p:spPr>
-          <a:xfrm>
-            <a:off x="-71220" y="4161302"/>
-            <a:ext cx="872067" cy="702734"/>
-          </a:xfrm>
-          <a:prstGeom prst="rect">
-            <a:avLst/>
-          </a:prstGeom>
-        </p:spPr>
-      </p:pic>
-      <p:pic>
-        <p:nvPicPr>
-          <p:cNvPr id="17" name="Graphic 16" descr="Checkbox Checked with solid fill">
-            <a:extLst>
-              <a:ext uri="{FF2B5EF4-FFF2-40B4-BE49-F238E27FC236}">
-                <a16:creationId xmlns:a16="http://schemas.microsoft.com/office/drawing/2014/main" id="{B95ED1C8-4A62-DBFD-CE02-855C24C21438}"/>
-              </a:ext>
-            </a:extLst>
-          </p:cNvPr>
-          <p:cNvPicPr>
-            <a:picLocks noChangeAspect="1"/>
-          </p:cNvPicPr>
-          <p:nvPr/>
-        </p:nvPicPr>
-        <p:blipFill>
-          <a:blip r:embed="rId8">
-            <a:extLst>
-              <a:ext uri="{96DAC541-7B7A-43D3-8B79-37D633B846F1}">
-                <asvg:svgBlip xmlns:asvg="http://schemas.microsoft.com/office/drawing/2016/SVG/main" r:embed="rId9"/>
-              </a:ext>
-            </a:extLst>
-          </a:blip>
-          <a:stretch>
-            <a:fillRect/>
-          </a:stretch>
-        </p:blipFill>
-        <p:spPr>
-          <a:xfrm>
-            <a:off x="-71220" y="4665670"/>
-            <a:ext cx="872067" cy="730956"/>
-          </a:xfrm>
-          <a:prstGeom prst="rect">
-            <a:avLst/>
-          </a:prstGeom>
-        </p:spPr>
-      </p:pic>
-      <p:pic>
-        <p:nvPicPr>
-          <p:cNvPr id="21" name="Graphic 20" descr="Checkbox Checked with solid fill">
-            <a:extLst>
-              <a:ext uri="{FF2B5EF4-FFF2-40B4-BE49-F238E27FC236}">
-                <a16:creationId xmlns:a16="http://schemas.microsoft.com/office/drawing/2014/main" id="{DB185661-75C2-A1B2-4A02-07705A119AB2}"/>
-              </a:ext>
-            </a:extLst>
-          </p:cNvPr>
-          <p:cNvPicPr>
-            <a:picLocks noChangeAspect="1"/>
-          </p:cNvPicPr>
-          <p:nvPr/>
-        </p:nvPicPr>
-        <p:blipFill>
-          <a:blip r:embed="rId8">
-            <a:extLst>
-              <a:ext uri="{96DAC541-7B7A-43D3-8B79-37D633B846F1}">
-                <asvg:svgBlip xmlns:asvg="http://schemas.microsoft.com/office/drawing/2016/SVG/main" r:embed="rId9"/>
-              </a:ext>
-            </a:extLst>
-          </a:blip>
-          <a:stretch>
-            <a:fillRect/>
-          </a:stretch>
-        </p:blipFill>
-        <p:spPr>
-          <a:xfrm>
-            <a:off x="-80423" y="5283774"/>
-            <a:ext cx="879429" cy="699054"/>
-          </a:xfrm>
-          <a:prstGeom prst="rect">
-            <a:avLst/>
-          </a:prstGeom>
-        </p:spPr>
-      </p:pic>
-      <p:pic>
-        <p:nvPicPr>
-          <p:cNvPr id="3" name="Picture 2">
-            <a:extLst>
-              <a:ext uri="{FF2B5EF4-FFF2-40B4-BE49-F238E27FC236}">
-                <a16:creationId xmlns:a16="http://schemas.microsoft.com/office/drawing/2014/main" id="{68369CED-A39D-26D9-2F5E-AB6A02DE440E}"/>
-              </a:ext>
-            </a:extLst>
-          </p:cNvPr>
-          <p:cNvPicPr>
-            <a:picLocks noChangeAspect="1"/>
-          </p:cNvPicPr>
-          <p:nvPr/>
-        </p:nvPicPr>
-        <p:blipFill>
-          <a:blip r:embed="rId10"/>
-          <a:stretch>
-            <a:fillRect/>
-          </a:stretch>
-        </p:blipFill>
-        <p:spPr>
-          <a:xfrm>
-            <a:off x="9203" y="2224157"/>
-            <a:ext cx="829813" cy="773368"/>
-          </a:xfrm>
-          <a:prstGeom prst="rect">
-            <a:avLst/>
-          </a:prstGeom>
-        </p:spPr>
-      </p:pic>
-      <p:pic>
-        <p:nvPicPr>
-          <p:cNvPr id="218" name="Picture 217">
-            <a:extLst>
-              <a:ext uri="{FF2B5EF4-FFF2-40B4-BE49-F238E27FC236}">
-                <a16:creationId xmlns:a16="http://schemas.microsoft.com/office/drawing/2014/main" id="{D5CF8785-6EBC-6E2A-63C0-A5B673A65F4F}"/>
-              </a:ext>
-            </a:extLst>
-          </p:cNvPr>
-          <p:cNvPicPr>
-            <a:picLocks noChangeAspect="1"/>
-          </p:cNvPicPr>
-          <p:nvPr/>
-        </p:nvPicPr>
-        <p:blipFill>
-          <a:blip r:embed="rId10"/>
-          <a:stretch>
-            <a:fillRect/>
-          </a:stretch>
-        </p:blipFill>
-        <p:spPr>
-          <a:xfrm>
-            <a:off x="-32805" y="3475310"/>
-            <a:ext cx="842592" cy="684442"/>
-          </a:xfrm>
-          <a:prstGeom prst="rect">
-            <a:avLst/>
-          </a:prstGeom>
-        </p:spPr>
-      </p:pic>
-      <p:pic>
-        <p:nvPicPr>
-          <p:cNvPr id="227" name="Picture 226">
-            <a:extLst>
-              <a:ext uri="{FF2B5EF4-FFF2-40B4-BE49-F238E27FC236}">
-                <a16:creationId xmlns:a16="http://schemas.microsoft.com/office/drawing/2014/main" id="{59945A64-5374-F54E-71F7-DD8BEBC5AA8A}"/>
-              </a:ext>
-            </a:extLst>
-          </p:cNvPr>
-          <p:cNvPicPr>
-            <a:picLocks noChangeAspect="1"/>
-          </p:cNvPicPr>
-          <p:nvPr/>
-        </p:nvPicPr>
-        <p:blipFill>
-          <a:blip r:embed="rId10"/>
-          <a:stretch>
-            <a:fillRect/>
-          </a:stretch>
-        </p:blipFill>
-        <p:spPr>
-          <a:xfrm>
-            <a:off x="37159" y="2768898"/>
-            <a:ext cx="716924" cy="787480"/>
-          </a:xfrm>
-          <a:prstGeom prst="rect">
-            <a:avLst/>
-          </a:prstGeom>
-        </p:spPr>
-      </p:pic>
-    </p:spTree>
-    <p:extLst>
-      <p:ext uri="{BB962C8B-B14F-4D97-AF65-F5344CB8AC3E}">
-        <p14:creationId xmlns:p14="http://schemas.microsoft.com/office/powerpoint/2010/main" val="3197113900"/>
-      </p:ext>
-    </p:extLst>
-  </p:cSld>
-  <p:clrMapOvr>
-    <a:masterClrMapping/>
-  </p:clrMapOvr>
-</p:sld>
-</file>
-
-<file path=ppt/slides/slide3.xml><?xml version="1.0" encoding="utf-8"?>
-<p:sld xmlns:a="http://schemas.openxmlformats.org/drawingml/2006/main" xmlns:r="http://schemas.openxmlformats.org/officeDocument/2006/relationships" xmlns:p="http://schemas.openxmlformats.org/presentationml/2006/main">
-  <p:cSld>
-    <p:bg>
-      <p:bgPr>
-        <a:solidFill>
-          <a:schemeClr val="bg1"/>
-        </a:solidFill>
-        <a:effectLst/>
-      </p:bgPr>
-    </p:bg>
-    <p:spTree>
-      <p:nvGrpSpPr>
-        <p:cNvPr id="1" name=""/>
-        <p:cNvGrpSpPr/>
-        <p:nvPr/>
-      </p:nvGrpSpPr>
-      <p:grpSpPr>
-        <a:xfrm>
-          <a:off x="0" y="0"/>
-          <a:ext cx="0" cy="0"/>
-          <a:chOff x="0" y="0"/>
-          <a:chExt cx="0" cy="0"/>
-        </a:xfrm>
-      </p:grpSpPr>
       <p:sp useBgFill="1">
         <p:nvSpPr>
           <p:cNvPr id="23" name="Rectangle 22">
@@ -8334,20 +7434,30 @@
           <a:lstStyle/>
           <a:p>
             <a:r>
-              <a:rPr lang="en-US" sz="2400" dirty="0"/>
-              <a:t>Wrote up or sprint plans and kept up with the documentation for the project</a:t>
+              <a:rPr lang="en-US" dirty="0"/>
+              <a:t>Task:  Sprint Leading</a:t>
             </a:r>
           </a:p>
           <a:p>
+            <a:pPr marL="0" indent="0">
+              <a:buNone/>
+            </a:pPr>
             <a:r>
-              <a:rPr lang="en-US" sz="2400" dirty="0"/>
-              <a:t>Created a template presentation we can use going forward</a:t>
+              <a:rPr lang="en-US" dirty="0"/>
+              <a:t>	- Sprint planning with Stories</a:t>
             </a:r>
           </a:p>
           <a:p>
+            <a:pPr marL="0" indent="0">
+              <a:buNone/>
+            </a:pPr>
             <a:r>
-              <a:rPr lang="en-US" sz="2400" dirty="0"/>
-              <a:t>Jumped around to whichever position needed the most support</a:t>
+              <a:rPr lang="en-US"/>
+              <a:t>	- </a:t>
+            </a:r>
+            <a:r>
+              <a:rPr lang="en-US" dirty="0"/>
+              <a:t>Sprint Retrospective and Review</a:t>
             </a:r>
           </a:p>
         </p:txBody>
@@ -8417,7 +7527,7 @@
 </p:sld>
 </file>
 
-<file path=ppt/slides/slide4.xml><?xml version="1.0" encoding="utf-8"?>
+<file path=ppt/slides/slide3.xml><?xml version="1.0" encoding="utf-8"?>
 <p:sld xmlns:a="http://schemas.openxmlformats.org/drawingml/2006/main" xmlns:r="http://schemas.openxmlformats.org/officeDocument/2006/relationships" xmlns:p="http://schemas.openxmlformats.org/presentationml/2006/main">
   <p:cSld>
     <p:bg>
@@ -8854,53 +7964,31 @@
           <a:lstStyle/>
           <a:p>
             <a:r>
-              <a:rPr lang="en-US" sz="2400"/>
-              <a:t>Chose The Golden Machine and set it up</a:t>
+              <a:rPr lang="en-US" dirty="0"/>
+              <a:t>Task: </a:t>
             </a:r>
-          </a:p>
-          <a:p>
-            <a:pPr lvl="1"/>
-            <a:r>
-              <a:rPr lang="en-US" sz="2000"/>
-              <a:t>Golden Machine Specs:</a:t>
-            </a:r>
-          </a:p>
-          <a:p>
-            <a:pPr lvl="2"/>
-            <a:r>
-              <a:rPr lang="en-US" sz="1600">
-                <a:ea typeface="+mn-lt"/>
-                <a:cs typeface="+mn-lt"/>
-              </a:rPr>
-              <a:t>Windows 11 Processor Intel(R) Xeon(R) w3-2435 (3.10 GHz) Graphics Card: NVIDIA RTX A4000 (16GB) Installed RAM 32.0 GB (31.3 GB usable) System type 64-bit operating system, x64-based processor Unreal Engine Version 5.7.3 Python 3.9.13</a:t>
-            </a:r>
-          </a:p>
-          <a:p>
-            <a:r>
-              <a:rPr lang="en-US" sz="2400"/>
-              <a:t>Created Set up instructions and updated as our project grew in sprint 2</a:t>
-            </a:r>
-          </a:p>
-          <a:p>
-            <a:pPr lvl="1"/>
-            <a:r>
-              <a:rPr lang="en-US" sz="2000"/>
-              <a:t>Will need to be edited due to changes we decided to make due to week 2's results</a:t>
-            </a:r>
-          </a:p>
-          <a:p>
-            <a:pPr lvl="1"/>
-            <a:endParaRPr lang="en-US" sz="2000"/>
           </a:p>
           <a:p>
             <a:pPr marL="0" indent="0">
               <a:buNone/>
             </a:pPr>
-            <a:endParaRPr lang="en-US" sz="1600"/>
+            <a:r>
+              <a:rPr lang="en-US" dirty="0"/>
+              <a:t>	- Verify that our project works on a fresh install</a:t>
+            </a:r>
+          </a:p>
+          <a:p>
+            <a:pPr marL="0" indent="0">
+              <a:buNone/>
+            </a:pPr>
+            <a:r>
+              <a:rPr lang="en-US" dirty="0"/>
+              <a:t>	- Validate on a second machine</a:t>
+            </a:r>
           </a:p>
           <a:p>
             <a:pPr lvl="2"/>
-            <a:endParaRPr lang="en-US" sz="1600"/>
+            <a:endParaRPr lang="en-US" sz="1600" dirty="0"/>
           </a:p>
         </p:txBody>
       </p:sp>
@@ -8969,7 +8057,7 @@
 </p:sld>
 </file>
 
-<file path=ppt/slides/slide5.xml><?xml version="1.0" encoding="utf-8"?>
+<file path=ppt/slides/slide4.xml><?xml version="1.0" encoding="utf-8"?>
 <p:sld xmlns:a="http://schemas.openxmlformats.org/drawingml/2006/main" xmlns:r="http://schemas.openxmlformats.org/officeDocument/2006/relationships" xmlns:p="http://schemas.openxmlformats.org/presentationml/2006/main">
   <p:cSld>
     <p:bg>
@@ -10104,7 +9192,7 @@
 </p:sld>
 </file>
 
-<file path=ppt/slides/slide6.xml><?xml version="1.0" encoding="utf-8"?>
+<file path=ppt/slides/slide5.xml><?xml version="1.0" encoding="utf-8"?>
 <p:sld xmlns:a="http://schemas.openxmlformats.org/drawingml/2006/main" xmlns:r="http://schemas.openxmlformats.org/officeDocument/2006/relationships" xmlns:p="http://schemas.openxmlformats.org/presentationml/2006/main">
   <p:cSld>
     <p:bg>
@@ -10623,7 +9711,7 @@
 </p:sld>
 </file>
 
-<file path=ppt/slides/slide7.xml><?xml version="1.0" encoding="utf-8"?>
+<file path=ppt/slides/slide6.xml><?xml version="1.0" encoding="utf-8"?>
 <p:sld xmlns:a="http://schemas.openxmlformats.org/drawingml/2006/main" xmlns:r="http://schemas.openxmlformats.org/officeDocument/2006/relationships" xmlns:p="http://schemas.openxmlformats.org/presentationml/2006/main">
   <p:cSld>
     <p:bg>
@@ -11064,52 +10152,6 @@
           </a:bodyPr>
           <a:lstStyle/>
           <a:p>
-            <a:r>
-              <a:rPr lang="en-US" sz="2400" dirty="0"/>
-              <a:t>Imported and set up Microsoft </a:t>
-            </a:r>
-            <a:r>
-              <a:rPr lang="en-US" sz="2400" dirty="0" err="1"/>
-              <a:t>AirSim</a:t>
-            </a:r>
-            <a:r>
-              <a:rPr lang="en-US" sz="2400" dirty="0"/>
-              <a:t> into the project</a:t>
-            </a:r>
-            <a:endParaRPr lang="en-US" dirty="0"/>
-          </a:p>
-          <a:p>
-            <a:pPr lvl="1">
-              <a:buFont typeface="Courier New" panose="020B0604020202020204" pitchFamily="34" charset="0"/>
-              <a:buChar char="o"/>
-            </a:pPr>
-            <a:r>
-              <a:rPr lang="en-US" sz="2000" dirty="0"/>
-              <a:t>Microsoft </a:t>
-            </a:r>
-            <a:r>
-              <a:rPr lang="en-US" sz="2000" dirty="0" err="1"/>
-              <a:t>Airsim</a:t>
-            </a:r>
-            <a:r>
-              <a:rPr lang="en-US" sz="2000" dirty="0"/>
-              <a:t> and other SDK's are </a:t>
-            </a:r>
-            <a:r>
-              <a:rPr lang="en-US" sz="2000" dirty="0" err="1"/>
-              <a:t>likley</a:t>
-            </a:r>
-            <a:r>
-              <a:rPr lang="en-US" sz="2000" dirty="0"/>
-              <a:t> not going to work for this </a:t>
-            </a:r>
-            <a:r>
-              <a:rPr lang="en-US" sz="2000" dirty="0" err="1"/>
-              <a:t>projet</a:t>
-            </a:r>
-            <a:endParaRPr lang="en-US" sz="2000" dirty="0"/>
-          </a:p>
-          <a:p>
             <a:endParaRPr lang="en-US" sz="2400" dirty="0"/>
           </a:p>
         </p:txBody>
@@ -11179,7 +10221,7 @@
 </p:sld>
 </file>
 
-<file path=ppt/slides/slide8.xml><?xml version="1.0" encoding="utf-8"?>
+<file path=ppt/slides/slide7.xml><?xml version="1.0" encoding="utf-8"?>
 <p:sld xmlns:a="http://schemas.openxmlformats.org/drawingml/2006/main" xmlns:r="http://schemas.openxmlformats.org/officeDocument/2006/relationships" xmlns:p="http://schemas.openxmlformats.org/presentationml/2006/main">
   <p:cSld>
     <p:bg>
@@ -11654,6 +10696,187 @@
     <p:extLst>
       <p:ext uri="{BB962C8B-B14F-4D97-AF65-F5344CB8AC3E}">
         <p14:creationId xmlns:p14="http://schemas.microsoft.com/office/powerpoint/2010/main" val="3353221219"/>
+      </p:ext>
+    </p:extLst>
+  </p:cSld>
+  <p:clrMapOvr>
+    <a:masterClrMapping/>
+  </p:clrMapOvr>
+</p:sld>
+</file>
+
+<file path=ppt/slides/slide8.xml><?xml version="1.0" encoding="utf-8"?>
+<p:sld xmlns:a="http://schemas.openxmlformats.org/drawingml/2006/main" xmlns:r="http://schemas.openxmlformats.org/officeDocument/2006/relationships" xmlns:p="http://schemas.openxmlformats.org/presentationml/2006/main">
+  <p:cSld>
+    <p:bg>
+      <p:bgPr>
+        <a:solidFill>
+          <a:schemeClr val="bg1"/>
+        </a:solidFill>
+        <a:effectLst/>
+      </p:bgPr>
+    </p:bg>
+    <p:spTree>
+      <p:nvGrpSpPr>
+        <p:cNvPr id="1" name=""/>
+        <p:cNvGrpSpPr/>
+        <p:nvPr/>
+      </p:nvGrpSpPr>
+      <p:grpSpPr>
+        <a:xfrm>
+          <a:off x="0" y="0"/>
+          <a:ext cx="0" cy="0"/>
+          <a:chOff x="0" y="0"/>
+          <a:chExt cx="0" cy="0"/>
+        </a:xfrm>
+      </p:grpSpPr>
+      <p:sp>
+        <p:nvSpPr>
+          <p:cNvPr id="24" name="Rectangle 23">
+            <a:extLst>
+              <a:ext uri="{FF2B5EF4-FFF2-40B4-BE49-F238E27FC236}">
+                <a16:creationId xmlns:a16="http://schemas.microsoft.com/office/drawing/2014/main" id="{B50AB553-2A96-4A92-96F2-93548E096954}"/>
+              </a:ext>
+              <a:ext uri="{C183D7F6-B498-43B3-948B-1728B52AA6E4}">
+                <adec:decorative xmlns:adec="http://schemas.microsoft.com/office/drawing/2017/decorative" val="1"/>
+              </a:ext>
+            </a:extLst>
+          </p:cNvPr>
+          <p:cNvSpPr>
+            <a:spLocks noGrp="1" noRot="1" noChangeAspect="1" noMove="1" noResize="1" noEditPoints="1" noAdjustHandles="1" noChangeArrowheads="1" noChangeShapeType="1" noTextEdit="1"/>
+          </p:cNvSpPr>
+          <p:nvPr>
+            <p:extLst>
+              <p:ext uri="{386F3935-93C4-4BCD-93E2-E3B085C9AB24}">
+                <p16:designElem xmlns:p16="http://schemas.microsoft.com/office/powerpoint/2015/main" val="1"/>
+              </p:ext>
+            </p:extLst>
+          </p:nvPr>
+        </p:nvSpPr>
+        <p:spPr>
+          <a:xfrm>
+            <a:off x="0" y="0"/>
+            <a:ext cx="12192000" cy="6858000"/>
+          </a:xfrm>
+          <a:prstGeom prst="rect">
+            <a:avLst/>
+          </a:prstGeom>
+          <a:gradFill>
+            <a:gsLst>
+              <a:gs pos="10000">
+                <a:schemeClr val="bg2">
+                  <a:alpha val="68000"/>
+                </a:schemeClr>
+              </a:gs>
+              <a:gs pos="85000">
+                <a:schemeClr val="bg2">
+                  <a:alpha val="97000"/>
+                </a:schemeClr>
+              </a:gs>
+            </a:gsLst>
+            <a:path path="circle">
+              <a:fillToRect l="50000" t="50000" r="50000" b="50000"/>
+            </a:path>
+          </a:gradFill>
+          <a:ln>
+            <a:noFill/>
+          </a:ln>
+        </p:spPr>
+        <p:style>
+          <a:lnRef idx="2">
+            <a:schemeClr val="accent1">
+              <a:shade val="50000"/>
+            </a:schemeClr>
+          </a:lnRef>
+          <a:fillRef idx="1">
+            <a:schemeClr val="accent1"/>
+          </a:fillRef>
+          <a:effectRef idx="0">
+            <a:schemeClr val="accent1"/>
+          </a:effectRef>
+          <a:fontRef idx="minor">
+            <a:schemeClr val="lt1"/>
+          </a:fontRef>
+        </p:style>
+        <p:txBody>
+          <a:bodyPr rtlCol="0" anchor="ctr"/>
+          <a:lstStyle/>
+          <a:p>
+            <a:pPr algn="ctr"/>
+            <a:endParaRPr lang="en-US"/>
+          </a:p>
+        </p:txBody>
+      </p:sp>
+      <p:sp>
+        <p:nvSpPr>
+          <p:cNvPr id="2" name="Title 1">
+            <a:extLst>
+              <a:ext uri="{FF2B5EF4-FFF2-40B4-BE49-F238E27FC236}">
+                <a16:creationId xmlns:a16="http://schemas.microsoft.com/office/drawing/2014/main" id="{2D7AF4BD-C9E6-DD9E-8AD0-9DAD0F65147F}"/>
+              </a:ext>
+            </a:extLst>
+          </p:cNvPr>
+          <p:cNvSpPr>
+            <a:spLocks noGrp="1"/>
+          </p:cNvSpPr>
+          <p:nvPr>
+            <p:ph type="title"/>
+          </p:nvPr>
+        </p:nvSpPr>
+        <p:spPr>
+          <a:xfrm>
+            <a:off x="838200" y="365125"/>
+            <a:ext cx="10515600" cy="1325563"/>
+          </a:xfrm>
+        </p:spPr>
+        <p:txBody>
+          <a:bodyPr>
+            <a:normAutofit/>
+          </a:bodyPr>
+          <a:lstStyle/>
+          <a:p>
+            <a:r>
+              <a:rPr lang="en-US"/>
+              <a:t>Deliverables</a:t>
+            </a:r>
+          </a:p>
+        </p:txBody>
+      </p:sp>
+      <p:graphicFrame>
+        <p:nvGraphicFramePr>
+          <p:cNvPr id="14" name="Content Placeholder 2">
+            <a:extLst>
+              <a:ext uri="{FF2B5EF4-FFF2-40B4-BE49-F238E27FC236}">
+                <a16:creationId xmlns:a16="http://schemas.microsoft.com/office/drawing/2014/main" id="{CB9FB94D-28CA-B8AF-E99E-B55D35733884}"/>
+              </a:ext>
+            </a:extLst>
+          </p:cNvPr>
+          <p:cNvGraphicFramePr>
+            <a:graphicFrameLocks noGrp="1"/>
+          </p:cNvGraphicFramePr>
+          <p:nvPr>
+            <p:ph idx="1"/>
+            <p:extLst>
+              <p:ext uri="{D42A27DB-BD31-4B8C-83A1-F6EECF244321}">
+                <p14:modId xmlns:p14="http://schemas.microsoft.com/office/powerpoint/2010/main" val="1216432367"/>
+              </p:ext>
+            </p:extLst>
+          </p:nvPr>
+        </p:nvGraphicFramePr>
+        <p:xfrm>
+          <a:off x="805068" y="1648929"/>
+          <a:ext cx="10504557" cy="4351338"/>
+        </p:xfrm>
+        <a:graphic>
+          <a:graphicData uri="http://schemas.openxmlformats.org/drawingml/2006/diagram">
+            <dgm:relIds xmlns:dgm="http://schemas.openxmlformats.org/drawingml/2006/diagram" xmlns:r="http://schemas.openxmlformats.org/officeDocument/2006/relationships" r:dm="rId2" r:lo="rId3" r:qs="rId4" r:cs="rId5"/>
+          </a:graphicData>
+        </a:graphic>
+      </p:graphicFrame>
+    </p:spTree>
+    <p:extLst>
+      <p:ext uri="{BB962C8B-B14F-4D97-AF65-F5344CB8AC3E}">
+        <p14:creationId xmlns:p14="http://schemas.microsoft.com/office/powerpoint/2010/main" val="3197113900"/>
       </p:ext>
     </p:extLst>
   </p:cSld>
@@ -12208,9 +11431,14 @@
           <a:lstStyle/>
           <a:p>
             <a:r>
-              <a:rPr lang="en-US" sz="2000"/>
-              <a:t>Create our own SDK</a:t>
+              <a:rPr lang="en-US" sz="2000" dirty="0"/>
+              <a:t>Migrate to Project </a:t>
             </a:r>
+            <a:r>
+              <a:rPr lang="en-US" sz="2000" dirty="0" err="1"/>
+              <a:t>AirSim</a:t>
+            </a:r>
+            <a:endParaRPr lang="en-US" sz="2000" dirty="0"/>
           </a:p>
           <a:p>
             <a:pPr lvl="1">
@@ -12218,44 +11446,33 @@
               <a:buChar char="o"/>
             </a:pPr>
             <a:r>
-              <a:rPr lang="en-US" sz="1600"/>
-              <a:t>This is was our biggest bottleneck for week 2 tasks</a:t>
+              <a:rPr lang="en-US" sz="1600" dirty="0"/>
+              <a:t>The Successor to Microsoft </a:t>
             </a:r>
-          </a:p>
-          <a:p>
-            <a:pPr lvl="1">
-              <a:buFont typeface="Courier New" panose="020B0604020202020204" pitchFamily="34" charset="0"/>
-              <a:buChar char="o"/>
+            <a:r>
+              <a:rPr lang="en-US" sz="1600" dirty="0" err="1"/>
+              <a:t>Airsim</a:t>
+            </a:r>
+            <a:r>
+              <a:rPr lang="en-US" sz="1600" dirty="0"/>
+              <a:t> Managed by IAMAI.</a:t>
+            </a:r>
+          </a:p>
+          <a:p>
+            <a:pPr marL="457200" lvl="1" indent="0">
+              <a:buNone/>
             </a:pPr>
             <a:r>
-              <a:rPr lang="en-US" sz="1600"/>
-              <a:t>The 3rd party SDK's are not going to work for this project and make the set up long and difficult.</a:t>
+              <a:rPr lang="en-US" sz="1600" dirty="0"/>
+              <a:t>That’s pretty much it!!</a:t>
             </a:r>
-          </a:p>
-          <a:p>
-            <a:r>
-              <a:rPr lang="en-US" sz="2000"/>
-              <a:t>Update meeting times</a:t>
-            </a:r>
-          </a:p>
-          <a:p>
-            <a:pPr lvl="1">
-              <a:buFont typeface="Courier New" panose="020B0604020202020204" pitchFamily="34" charset="0"/>
-              <a:buChar char="o"/>
-            </a:pPr>
-            <a:r>
-              <a:rPr lang="en-US" sz="1600"/>
-              <a:t>We need to work around balancing our meetings times a little better to make sure that we are able to get work done consistently.</a:t>
-            </a:r>
-          </a:p>
-          <a:p>
-            <a:endParaRPr lang="en-US" sz="2000"/>
+            <a:endParaRPr lang="en-US" sz="2000" dirty="0"/>
           </a:p>
           <a:p>
             <a:pPr marL="914400" lvl="2" indent="0">
               <a:buNone/>
             </a:pPr>
-            <a:endParaRPr lang="en-US" sz="1200"/>
+            <a:endParaRPr lang="en-US" sz="1200" dirty="0"/>
           </a:p>
         </p:txBody>
       </p:sp>

</xml_diff>